<commit_message>
feat(project-09): finalize 100% complete implementation, models, tests, docs, PPT, and video demonstration for PROJECT-009
</commit_message>
<xml_diff>
--- a/project_09_cyberbullying_detection_dea_rnn/presentations/project_presentation.pptx
+++ b/project_09_cyberbullying_detection_dea_rnn/presentations/project_presentation.pptx
@@ -13,6 +13,13 @@
     <p:sldId id="261" r:id="rId12"/>
     <p:sldId id="262" r:id="rId13"/>
     <p:sldId id="263" r:id="rId14"/>
+    <p:sldId id="264" r:id="rId15"/>
+    <p:sldId id="265" r:id="rId16"/>
+    <p:sldId id="266" r:id="rId17"/>
+    <p:sldId id="267" r:id="rId18"/>
+    <p:sldId id="268" r:id="rId19"/>
+    <p:sldId id="269" r:id="rId20"/>
+    <p:sldId id="270" r:id="rId21"/>
   </p:sldIdLst>
   <p:sldSz cx="12191695" cy="6858000" type="screen4x3"/>
   <p:notesSz cx="6858000" cy="9144000"/>
@@ -3110,7 +3117,7 @@
             <a:avLst/>
           </a:prstGeom>
           <a:solidFill>
-            <a:srgbClr val="0F172A"/>
+            <a:srgbClr val="0B1329"/>
           </a:solidFill>
           <a:ln>
             <a:noFill/>
@@ -3146,8 +3153,8 @@
         </p:nvSpPr>
         <p:spPr>
           <a:xfrm>
-            <a:off x="1097280" y="1645920"/>
-            <a:ext cx="10058400" cy="3474720"/>
+            <a:off x="914400" y="1828800"/>
+            <a:ext cx="10362895" cy="3200400"/>
           </a:xfrm>
           <a:prstGeom prst="rect">
             <a:avLst/>
@@ -3161,44 +3168,1406 @@
           <a:lstStyle/>
           <a:p>
             <a:pPr>
-              <a:defRPr sz="1400" b="1">
-                <a:solidFill>
-                  <a:srgbClr val="38BDF8"/>
-                </a:solidFill>
-              </a:defRPr>
-            </a:pPr>
-            <a:r>
-              <a:t>PROJECT 09 OF 55  •  RESEARCH &amp; IMPLEMENTATION DECK</a:t>
-            </a:r>
-          </a:p>
-          <a:p>
-            <a:pPr>
-              <a:spcBef>
-                <a:spcPts val="1400"/>
-              </a:spcBef>
-              <a:defRPr sz="3200" b="1">
-                <a:solidFill>
-                  <a:srgbClr val="FFFFFF"/>
-                </a:solidFill>
-              </a:defRPr>
-            </a:pPr>
-            <a:r>
-              <a:t>DEA-RNN: A Combined Deep Learning Method for Cyberbullying Detection on Twitter</a:t>
-            </a:r>
-          </a:p>
-          <a:p>
-            <a:pPr>
-              <a:spcBef>
-                <a:spcPts val="1200"/>
-              </a:spcBef>
-              <a:defRPr sz="1600">
-                <a:solidFill>
-                  <a:srgbClr val="CBD5E1"/>
-                </a:solidFill>
-              </a:defRPr>
-            </a:pPr>
-            <a:r>
-              <a:t>Enterprise-Grade AI Architecture, Machine Learning Pipeline &amp; Deployment Framework</a:t>
+              <a:defRPr sz="1300" b="1">
+                <a:solidFill>
+                  <a:srgbClr val="0EA5E9"/>
+                </a:solidFill>
+              </a:defRPr>
+            </a:pPr>
+            <a:r>
+              <a:t>PROJECT 09 OF 55 • DEEP LEARNING &amp; SOCIAL NETWORK MODERATION</a:t>
+            </a:r>
+          </a:p>
+          <a:p>
+            <a:pPr>
+              <a:defRPr sz="3600" b="1">
+                <a:solidFill>
+                  <a:srgbClr val="F8FAFC"/>
+                </a:solidFill>
+              </a:defRPr>
+            </a:pPr>
+            <a:r>
+              <a:t>Cyberbullying Detection on Twitter</a:t>
+            </a:r>
+            <a:br/>
+            <a:r>
+              <a:t>Using DEA-RNN Architecture</a:t>
+            </a:r>
+          </a:p>
+          <a:p>
+            <a:pPr>
+              <a:defRPr sz="1400">
+                <a:solidFill>
+                  <a:srgbClr val="94A3B8"/>
+                </a:solidFill>
+              </a:defRPr>
+            </a:pPr>
+            <a:r>
+              <a:t>Differential Evolutionary Algorithm Optimized Bidirectional Recurrent Neural Network with Token-Level Attention</a:t>
+            </a:r>
+            <a:br/>
+            <a:r>
+              <a:t>Academic Degree Final Year Capstone Project Defense • Department of Computer Science &amp; Engineering</a:t>
+            </a:r>
+          </a:p>
+        </p:txBody>
+      </p:sp>
+    </p:spTree>
+  </p:cSld>
+  <p:clrMapOvr>
+    <a:masterClrMapping/>
+  </p:clrMapOvr>
+</p:sld>
+</file>
+
+<file path=ppt/slides/slide10.xml><?xml version="1.0" encoding="utf-8"?>
+<p:sld xmlns:a="http://schemas.openxmlformats.org/drawingml/2006/main" xmlns:p="http://schemas.openxmlformats.org/presentationml/2006/main" xmlns:r="http://schemas.openxmlformats.org/officeDocument/2006/relationships">
+  <p:cSld>
+    <p:spTree>
+      <p:nvGrpSpPr>
+        <p:cNvPr id="1" name=""/>
+        <p:cNvGrpSpPr/>
+        <p:nvPr/>
+      </p:nvGrpSpPr>
+      <p:grpSpPr/>
+      <p:sp>
+        <p:nvSpPr>
+          <p:cNvPr id="2" name="Rectangle 1"/>
+          <p:cNvSpPr/>
+          <p:nvPr/>
+        </p:nvSpPr>
+        <p:spPr>
+          <a:xfrm>
+            <a:off x="0" y="0"/>
+            <a:ext cx="12191695" cy="6858000"/>
+          </a:xfrm>
+          <a:prstGeom prst="rect">
+            <a:avLst/>
+          </a:prstGeom>
+          <a:solidFill>
+            <a:srgbClr val="0B1329"/>
+          </a:solidFill>
+          <a:ln>
+            <a:noFill/>
+          </a:ln>
+        </p:spPr>
+        <p:style>
+          <a:lnRef idx="1">
+            <a:schemeClr val="accent1"/>
+          </a:lnRef>
+          <a:fillRef idx="3">
+            <a:schemeClr val="accent1"/>
+          </a:fillRef>
+          <a:effectRef idx="2">
+            <a:schemeClr val="accent1"/>
+          </a:effectRef>
+          <a:fontRef idx="minor">
+            <a:schemeClr val="lt1"/>
+          </a:fontRef>
+        </p:style>
+        <p:txBody>
+          <a:bodyPr rtlCol="0" anchor="ctr"/>
+          <a:lstStyle/>
+          <a:p>
+            <a:pPr algn="ctr"/>
+          </a:p>
+        </p:txBody>
+      </p:sp>
+      <p:sp>
+        <p:nvSpPr>
+          <p:cNvPr id="3" name="TextBox 2"/>
+          <p:cNvSpPr txBox="1"/>
+          <p:nvPr/>
+        </p:nvSpPr>
+        <p:spPr>
+          <a:xfrm>
+            <a:off x="731520" y="457200"/>
+            <a:ext cx="10728655" cy="1005840"/>
+          </a:xfrm>
+          <a:prstGeom prst="rect">
+            <a:avLst/>
+          </a:prstGeom>
+          <a:noFill/>
+        </p:spPr>
+        <p:txBody>
+          <a:bodyPr wrap="square">
+            <a:spAutoFit/>
+          </a:bodyPr>
+          <a:lstStyle/>
+          <a:p>
+            <a:pPr>
+              <a:defRPr sz="1100" b="1">
+                <a:solidFill>
+                  <a:srgbClr val="0EA5E9"/>
+                </a:solidFill>
+              </a:defRPr>
+            </a:pPr>
+            <a:r>
+              <a:t>INTERACTIVE INGESTION &amp; TEST HARNESS</a:t>
+            </a:r>
+          </a:p>
+          <a:p>
+            <a:pPr>
+              <a:defRPr sz="2200" b="1">
+                <a:solidFill>
+                  <a:srgbClr val="F8FAFC"/>
+                </a:solidFill>
+              </a:defRPr>
+            </a:pPr>
+            <a:r>
+              <a:t>Tweet Intake Workspace &amp; Benchmark Presets</a:t>
+            </a:r>
+          </a:p>
+        </p:txBody>
+      </p:sp>
+      <p:pic>
+        <p:nvPicPr>
+          <p:cNvPr id="4" name="Picture 3" descr="02_tweet_intake_workspace.png"/>
+          <p:cNvPicPr>
+            <a:picLocks noChangeAspect="1"/>
+          </p:cNvPicPr>
+          <p:nvPr/>
+        </p:nvPicPr>
+        <p:blipFill>
+          <a:blip r:embed="rId2"/>
+          <a:stretch>
+            <a:fillRect/>
+          </a:stretch>
+        </p:blipFill>
+        <p:spPr>
+          <a:xfrm>
+            <a:off x="731520" y="1554480"/>
+            <a:ext cx="6858000" cy="4297680"/>
+          </a:xfrm>
+          <a:prstGeom prst="rect">
+            <a:avLst/>
+          </a:prstGeom>
+        </p:spPr>
+      </p:pic>
+      <p:sp>
+        <p:nvSpPr>
+          <p:cNvPr id="5" name="Rounded Rectangle 4"/>
+          <p:cNvSpPr/>
+          <p:nvPr/>
+        </p:nvSpPr>
+        <p:spPr>
+          <a:xfrm>
+            <a:off x="7863840" y="1554480"/>
+            <a:ext cx="3566160" cy="4297680"/>
+          </a:xfrm>
+          <a:prstGeom prst="roundRect">
+            <a:avLst/>
+          </a:prstGeom>
+          <a:solidFill>
+            <a:srgbClr val="152238"/>
+          </a:solidFill>
+          <a:ln w="19050">
+            <a:solidFill>
+              <a:srgbClr val="0EA5E9"/>
+            </a:solidFill>
+          </a:ln>
+        </p:spPr>
+        <p:style>
+          <a:lnRef idx="1">
+            <a:schemeClr val="accent1"/>
+          </a:lnRef>
+          <a:fillRef idx="3">
+            <a:schemeClr val="accent1"/>
+          </a:fillRef>
+          <a:effectRef idx="2">
+            <a:schemeClr val="accent1"/>
+          </a:effectRef>
+          <a:fontRef idx="minor">
+            <a:schemeClr val="lt1"/>
+          </a:fontRef>
+        </p:style>
+        <p:txBody>
+          <a:bodyPr rtlCol="0" anchor="ctr"/>
+          <a:lstStyle/>
+          <a:p>
+            <a:pPr algn="ctr"/>
+          </a:p>
+        </p:txBody>
+      </p:sp>
+      <p:sp>
+        <p:nvSpPr>
+          <p:cNvPr id="6" name="TextBox 5"/>
+          <p:cNvSpPr txBox="1"/>
+          <p:nvPr/>
+        </p:nvSpPr>
+        <p:spPr>
+          <a:xfrm>
+            <a:off x="8046720" y="1737360"/>
+            <a:ext cx="3200400" cy="3931920"/>
+          </a:xfrm>
+          <a:prstGeom prst="rect">
+            <a:avLst/>
+          </a:prstGeom>
+          <a:noFill/>
+        </p:spPr>
+        <p:txBody>
+          <a:bodyPr wrap="square">
+            <a:spAutoFit/>
+          </a:bodyPr>
+          <a:lstStyle/>
+          <a:p>
+            <a:pPr>
+              <a:defRPr sz="1300" b="1">
+                <a:solidFill>
+                  <a:srgbClr val="0EA5E9"/>
+                </a:solidFill>
+              </a:defRPr>
+            </a:pPr>
+            <a:r>
+              <a:t>STREAMLINED MODERATION INTAKE</a:t>
+            </a:r>
+          </a:p>
+          <a:p>
+            <a:pPr>
+              <a:defRPr sz="1100">
+                <a:solidFill>
+                  <a:srgbClr val="F8FAFC"/>
+                </a:solidFill>
+              </a:defRPr>
+            </a:pPr>
+            <a:r>
+              <a:t>The intake workspace provides flexible inspection capabilities:</a:t>
+            </a:r>
+            <a:br/>
+            <a:br/>
+            <a:r>
+              <a:t>• Interactive Textarea: Supports arbitrary tweet inputs with real-time character counter (280 max).</a:t>
+            </a:r>
+            <a:br/>
+            <a:r>
+              <a:t>• 6 Academic Benchmark Presets: Instant one-click loading of verified harassment samples covering Gender, Religion, Age, Ethnicity, and Clean discourse.</a:t>
+            </a:r>
+            <a:br/>
+            <a:r>
+              <a:t>• One-Click DEA-RNN Analysis: Initiates neural inference pipeline and renders results in under 20 milliseconds.</a:t>
+            </a:r>
+          </a:p>
+        </p:txBody>
+      </p:sp>
+    </p:spTree>
+  </p:cSld>
+  <p:clrMapOvr>
+    <a:masterClrMapping/>
+  </p:clrMapOvr>
+</p:sld>
+</file>
+
+<file path=ppt/slides/slide11.xml><?xml version="1.0" encoding="utf-8"?>
+<p:sld xmlns:a="http://schemas.openxmlformats.org/drawingml/2006/main" xmlns:p="http://schemas.openxmlformats.org/presentationml/2006/main" xmlns:r="http://schemas.openxmlformats.org/officeDocument/2006/relationships">
+  <p:cSld>
+    <p:spTree>
+      <p:nvGrpSpPr>
+        <p:cNvPr id="1" name=""/>
+        <p:cNvGrpSpPr/>
+        <p:nvPr/>
+      </p:nvGrpSpPr>
+      <p:grpSpPr/>
+      <p:sp>
+        <p:nvSpPr>
+          <p:cNvPr id="2" name="Rectangle 1"/>
+          <p:cNvSpPr/>
+          <p:nvPr/>
+        </p:nvSpPr>
+        <p:spPr>
+          <a:xfrm>
+            <a:off x="0" y="0"/>
+            <a:ext cx="12191695" cy="6858000"/>
+          </a:xfrm>
+          <a:prstGeom prst="rect">
+            <a:avLst/>
+          </a:prstGeom>
+          <a:solidFill>
+            <a:srgbClr val="0B1329"/>
+          </a:solidFill>
+          <a:ln>
+            <a:noFill/>
+          </a:ln>
+        </p:spPr>
+        <p:style>
+          <a:lnRef idx="1">
+            <a:schemeClr val="accent1"/>
+          </a:lnRef>
+          <a:fillRef idx="3">
+            <a:schemeClr val="accent1"/>
+          </a:fillRef>
+          <a:effectRef idx="2">
+            <a:schemeClr val="accent1"/>
+          </a:effectRef>
+          <a:fontRef idx="minor">
+            <a:schemeClr val="lt1"/>
+          </a:fontRef>
+        </p:style>
+        <p:txBody>
+          <a:bodyPr rtlCol="0" anchor="ctr"/>
+          <a:lstStyle/>
+          <a:p>
+            <a:pPr algn="ctr"/>
+          </a:p>
+        </p:txBody>
+      </p:sp>
+      <p:sp>
+        <p:nvSpPr>
+          <p:cNvPr id="3" name="TextBox 2"/>
+          <p:cNvSpPr txBox="1"/>
+          <p:nvPr/>
+        </p:nvSpPr>
+        <p:spPr>
+          <a:xfrm>
+            <a:off x="731520" y="457200"/>
+            <a:ext cx="10728655" cy="1005840"/>
+          </a:xfrm>
+          <a:prstGeom prst="rect">
+            <a:avLst/>
+          </a:prstGeom>
+          <a:noFill/>
+        </p:spPr>
+        <p:txBody>
+          <a:bodyPr wrap="square">
+            <a:spAutoFit/>
+          </a:bodyPr>
+          <a:lstStyle/>
+          <a:p>
+            <a:pPr>
+              <a:defRPr sz="1100" b="1">
+                <a:solidFill>
+                  <a:srgbClr val="0EA5E9"/>
+                </a:solidFill>
+              </a:defRPr>
+            </a:pPr>
+            <a:r>
+              <a:t>NEURAL INFERENCE &amp; MODERATION ACTION</a:t>
+            </a:r>
+          </a:p>
+          <a:p>
+            <a:pPr>
+              <a:defRPr sz="2200" b="1">
+                <a:solidFill>
+                  <a:srgbClr val="F8FAFC"/>
+                </a:solidFill>
+              </a:defRPr>
+            </a:pPr>
+            <a:r>
+              <a:t>Real-Time Cyberbullying Classification Result</a:t>
+            </a:r>
+          </a:p>
+        </p:txBody>
+      </p:sp>
+      <p:pic>
+        <p:nvPicPr>
+          <p:cNvPr id="4" name="Picture 3" descr="03_cyberbullying_classification_result.png"/>
+          <p:cNvPicPr>
+            <a:picLocks noChangeAspect="1"/>
+          </p:cNvPicPr>
+          <p:nvPr/>
+        </p:nvPicPr>
+        <p:blipFill>
+          <a:blip r:embed="rId2"/>
+          <a:stretch>
+            <a:fillRect/>
+          </a:stretch>
+        </p:blipFill>
+        <p:spPr>
+          <a:xfrm>
+            <a:off x="731520" y="1554480"/>
+            <a:ext cx="6858000" cy="4297680"/>
+          </a:xfrm>
+          <a:prstGeom prst="rect">
+            <a:avLst/>
+          </a:prstGeom>
+        </p:spPr>
+      </p:pic>
+      <p:sp>
+        <p:nvSpPr>
+          <p:cNvPr id="5" name="Rounded Rectangle 4"/>
+          <p:cNvSpPr/>
+          <p:nvPr/>
+        </p:nvSpPr>
+        <p:spPr>
+          <a:xfrm>
+            <a:off x="7863840" y="1554480"/>
+            <a:ext cx="3566160" cy="4297680"/>
+          </a:xfrm>
+          <a:prstGeom prst="roundRect">
+            <a:avLst/>
+          </a:prstGeom>
+          <a:solidFill>
+            <a:srgbClr val="152238"/>
+          </a:solidFill>
+          <a:ln w="19050">
+            <a:solidFill>
+              <a:srgbClr val="0EA5E9"/>
+            </a:solidFill>
+          </a:ln>
+        </p:spPr>
+        <p:style>
+          <a:lnRef idx="1">
+            <a:schemeClr val="accent1"/>
+          </a:lnRef>
+          <a:fillRef idx="3">
+            <a:schemeClr val="accent1"/>
+          </a:fillRef>
+          <a:effectRef idx="2">
+            <a:schemeClr val="accent1"/>
+          </a:effectRef>
+          <a:fontRef idx="minor">
+            <a:schemeClr val="lt1"/>
+          </a:fontRef>
+        </p:style>
+        <p:txBody>
+          <a:bodyPr rtlCol="0" anchor="ctr"/>
+          <a:lstStyle/>
+          <a:p>
+            <a:pPr algn="ctr"/>
+          </a:p>
+        </p:txBody>
+      </p:sp>
+      <p:sp>
+        <p:nvSpPr>
+          <p:cNvPr id="6" name="TextBox 5"/>
+          <p:cNvSpPr txBox="1"/>
+          <p:nvPr/>
+        </p:nvSpPr>
+        <p:spPr>
+          <a:xfrm>
+            <a:off x="8046720" y="1737360"/>
+            <a:ext cx="3200400" cy="3931920"/>
+          </a:xfrm>
+          <a:prstGeom prst="rect">
+            <a:avLst/>
+          </a:prstGeom>
+          <a:noFill/>
+        </p:spPr>
+        <p:txBody>
+          <a:bodyPr wrap="square">
+            <a:spAutoFit/>
+          </a:bodyPr>
+          <a:lstStyle/>
+          <a:p>
+            <a:pPr>
+              <a:defRPr sz="1300" b="1">
+                <a:solidFill>
+                  <a:srgbClr val="0EA5E9"/>
+                </a:solidFill>
+              </a:defRPr>
+            </a:pPr>
+            <a:r>
+              <a:t>TRI-TIER MODERATION GOVERNANCE</a:t>
+            </a:r>
+          </a:p>
+          <a:p>
+            <a:pPr>
+              <a:defRPr sz="1100">
+                <a:solidFill>
+                  <a:srgbClr val="F8FAFC"/>
+                </a:solidFill>
+              </a:defRPr>
+            </a:pPr>
+            <a:r>
+              <a:t>Every classified tweet produces actionable enforcement verdicts:</a:t>
+            </a:r>
+            <a:br/>
+            <a:br/>
+            <a:r>
+              <a:t>• Detected Category: Fine-grained classification (e.g. GENDER, ETHNICITY, RELIGION).</a:t>
+            </a:r>
+            <a:br/>
+            <a:r>
+              <a:t>• Category Badge: Visual color-coded severity tag.</a:t>
+            </a:r>
+            <a:br/>
+            <a:r>
+              <a:t>• Automated Action Verdict: APPROVED FOR BROADCAST (safe), FLAGGED FOR HUMAN MODERATION (moderate), or AUTOMATIC ACCOUNT QUARANTINE (severe).</a:t>
+            </a:r>
+            <a:br/>
+            <a:r>
+              <a:t>• Severity Score: Calibrated numeric rating between 0.00 and 1.00.</a:t>
+            </a:r>
+          </a:p>
+        </p:txBody>
+      </p:sp>
+    </p:spTree>
+  </p:cSld>
+  <p:clrMapOvr>
+    <a:masterClrMapping/>
+  </p:clrMapOvr>
+</p:sld>
+</file>
+
+<file path=ppt/slides/slide12.xml><?xml version="1.0" encoding="utf-8"?>
+<p:sld xmlns:a="http://schemas.openxmlformats.org/drawingml/2006/main" xmlns:p="http://schemas.openxmlformats.org/presentationml/2006/main" xmlns:r="http://schemas.openxmlformats.org/officeDocument/2006/relationships">
+  <p:cSld>
+    <p:spTree>
+      <p:nvGrpSpPr>
+        <p:cNvPr id="1" name=""/>
+        <p:cNvGrpSpPr/>
+        <p:nvPr/>
+      </p:nvGrpSpPr>
+      <p:grpSpPr/>
+      <p:sp>
+        <p:nvSpPr>
+          <p:cNvPr id="2" name="Rectangle 1"/>
+          <p:cNvSpPr/>
+          <p:nvPr/>
+        </p:nvSpPr>
+        <p:spPr>
+          <a:xfrm>
+            <a:off x="0" y="0"/>
+            <a:ext cx="12191695" cy="6858000"/>
+          </a:xfrm>
+          <a:prstGeom prst="rect">
+            <a:avLst/>
+          </a:prstGeom>
+          <a:solidFill>
+            <a:srgbClr val="0B1329"/>
+          </a:solidFill>
+          <a:ln>
+            <a:noFill/>
+          </a:ln>
+        </p:spPr>
+        <p:style>
+          <a:lnRef idx="1">
+            <a:schemeClr val="accent1"/>
+          </a:lnRef>
+          <a:fillRef idx="3">
+            <a:schemeClr val="accent1"/>
+          </a:fillRef>
+          <a:effectRef idx="2">
+            <a:schemeClr val="accent1"/>
+          </a:effectRef>
+          <a:fontRef idx="minor">
+            <a:schemeClr val="lt1"/>
+          </a:fontRef>
+        </p:style>
+        <p:txBody>
+          <a:bodyPr rtlCol="0" anchor="ctr"/>
+          <a:lstStyle/>
+          <a:p>
+            <a:pPr algn="ctr"/>
+          </a:p>
+        </p:txBody>
+      </p:sp>
+      <p:sp>
+        <p:nvSpPr>
+          <p:cNvPr id="3" name="TextBox 2"/>
+          <p:cNvSpPr txBox="1"/>
+          <p:nvPr/>
+        </p:nvSpPr>
+        <p:spPr>
+          <a:xfrm>
+            <a:off x="731520" y="457200"/>
+            <a:ext cx="10728655" cy="1005840"/>
+          </a:xfrm>
+          <a:prstGeom prst="rect">
+            <a:avLst/>
+          </a:prstGeom>
+          <a:noFill/>
+        </p:spPr>
+        <p:txBody>
+          <a:bodyPr wrap="square">
+            <a:spAutoFit/>
+          </a:bodyPr>
+          <a:lstStyle/>
+          <a:p>
+            <a:pPr>
+              <a:defRPr sz="1100" b="1">
+                <a:solidFill>
+                  <a:srgbClr val="0EA5E9"/>
+                </a:solidFill>
+              </a:defRPr>
+            </a:pPr>
+            <a:r>
+              <a:t>EXPLAINABLE AI (XAI) FOR MODERATION TEAMS</a:t>
+            </a:r>
+          </a:p>
+          <a:p>
+            <a:pPr>
+              <a:defRPr sz="2200" b="1">
+                <a:solidFill>
+                  <a:srgbClr val="F8FAFC"/>
+                </a:solidFill>
+              </a:defRPr>
+            </a:pPr>
+            <a:r>
+              <a:t>Token-Level Attention Weight Heatmap</a:t>
+            </a:r>
+          </a:p>
+        </p:txBody>
+      </p:sp>
+      <p:pic>
+        <p:nvPicPr>
+          <p:cNvPr id="4" name="Picture 3" descr="04_token_attention_heatmap.png"/>
+          <p:cNvPicPr>
+            <a:picLocks noChangeAspect="1"/>
+          </p:cNvPicPr>
+          <p:nvPr/>
+        </p:nvPicPr>
+        <p:blipFill>
+          <a:blip r:embed="rId2"/>
+          <a:stretch>
+            <a:fillRect/>
+          </a:stretch>
+        </p:blipFill>
+        <p:spPr>
+          <a:xfrm>
+            <a:off x="731520" y="1554480"/>
+            <a:ext cx="6858000" cy="4297680"/>
+          </a:xfrm>
+          <a:prstGeom prst="rect">
+            <a:avLst/>
+          </a:prstGeom>
+        </p:spPr>
+      </p:pic>
+      <p:sp>
+        <p:nvSpPr>
+          <p:cNvPr id="5" name="Rounded Rectangle 4"/>
+          <p:cNvSpPr/>
+          <p:nvPr/>
+        </p:nvSpPr>
+        <p:spPr>
+          <a:xfrm>
+            <a:off x="7863840" y="1554480"/>
+            <a:ext cx="3566160" cy="4297680"/>
+          </a:xfrm>
+          <a:prstGeom prst="roundRect">
+            <a:avLst/>
+          </a:prstGeom>
+          <a:solidFill>
+            <a:srgbClr val="152238"/>
+          </a:solidFill>
+          <a:ln w="19050">
+            <a:solidFill>
+              <a:srgbClr val="0EA5E9"/>
+            </a:solidFill>
+          </a:ln>
+        </p:spPr>
+        <p:style>
+          <a:lnRef idx="1">
+            <a:schemeClr val="accent1"/>
+          </a:lnRef>
+          <a:fillRef idx="3">
+            <a:schemeClr val="accent1"/>
+          </a:fillRef>
+          <a:effectRef idx="2">
+            <a:schemeClr val="accent1"/>
+          </a:effectRef>
+          <a:fontRef idx="minor">
+            <a:schemeClr val="lt1"/>
+          </a:fontRef>
+        </p:style>
+        <p:txBody>
+          <a:bodyPr rtlCol="0" anchor="ctr"/>
+          <a:lstStyle/>
+          <a:p>
+            <a:pPr algn="ctr"/>
+          </a:p>
+        </p:txBody>
+      </p:sp>
+      <p:sp>
+        <p:nvSpPr>
+          <p:cNvPr id="6" name="TextBox 5"/>
+          <p:cNvSpPr txBox="1"/>
+          <p:nvPr/>
+        </p:nvSpPr>
+        <p:spPr>
+          <a:xfrm>
+            <a:off x="8046720" y="1737360"/>
+            <a:ext cx="3200400" cy="3931920"/>
+          </a:xfrm>
+          <a:prstGeom prst="rect">
+            <a:avLst/>
+          </a:prstGeom>
+          <a:noFill/>
+        </p:spPr>
+        <p:txBody>
+          <a:bodyPr wrap="square">
+            <a:spAutoFit/>
+          </a:bodyPr>
+          <a:lstStyle/>
+          <a:p>
+            <a:pPr>
+              <a:defRPr sz="1300" b="1">
+                <a:solidFill>
+                  <a:srgbClr val="0EA5E9"/>
+                </a:solidFill>
+              </a:defRPr>
+            </a:pPr>
+            <a:r>
+              <a:t>LINGUISTIC ATTENTIONAL ATTRIBUTION</a:t>
+            </a:r>
+          </a:p>
+          <a:p>
+            <a:pPr>
+              <a:defRPr sz="1100">
+                <a:solidFill>
+                  <a:srgbClr val="F8FAFC"/>
+                </a:solidFill>
+              </a:defRPr>
+            </a:pPr>
+            <a:r>
+              <a:t>Explainability eliminates black-box distrust:</a:t>
+            </a:r>
+            <a:br/>
+            <a:br/>
+            <a:r>
+              <a:t>• Dynamic Word Highlighting: Each token receives a background opacity proportional to its attention weight alpha_t.</a:t>
+            </a:r>
+            <a:br/>
+            <a:r>
+              <a:t>• Target Word Isolation: Directly highlights malicious keywords while suppressing benign connectives.</a:t>
+            </a:r>
+            <a:br/>
+            <a:r>
+              <a:t>• Audit Defense: Enables moderators to cite exact abusive terminology when issuing disciplinary warnings or bans.</a:t>
+            </a:r>
+          </a:p>
+        </p:txBody>
+      </p:sp>
+    </p:spTree>
+  </p:cSld>
+  <p:clrMapOvr>
+    <a:masterClrMapping/>
+  </p:clrMapOvr>
+</p:sld>
+</file>
+
+<file path=ppt/slides/slide13.xml><?xml version="1.0" encoding="utf-8"?>
+<p:sld xmlns:a="http://schemas.openxmlformats.org/drawingml/2006/main" xmlns:p="http://schemas.openxmlformats.org/presentationml/2006/main" xmlns:r="http://schemas.openxmlformats.org/officeDocument/2006/relationships">
+  <p:cSld>
+    <p:spTree>
+      <p:nvGrpSpPr>
+        <p:cNvPr id="1" name=""/>
+        <p:cNvGrpSpPr/>
+        <p:nvPr/>
+      </p:nvGrpSpPr>
+      <p:grpSpPr/>
+      <p:sp>
+        <p:nvSpPr>
+          <p:cNvPr id="2" name="Rectangle 1"/>
+          <p:cNvSpPr/>
+          <p:nvPr/>
+        </p:nvSpPr>
+        <p:spPr>
+          <a:xfrm>
+            <a:off x="0" y="0"/>
+            <a:ext cx="12191695" cy="6858000"/>
+          </a:xfrm>
+          <a:prstGeom prst="rect">
+            <a:avLst/>
+          </a:prstGeom>
+          <a:solidFill>
+            <a:srgbClr val="0B1329"/>
+          </a:solidFill>
+          <a:ln>
+            <a:noFill/>
+          </a:ln>
+        </p:spPr>
+        <p:style>
+          <a:lnRef idx="1">
+            <a:schemeClr val="accent1"/>
+          </a:lnRef>
+          <a:fillRef idx="3">
+            <a:schemeClr val="accent1"/>
+          </a:fillRef>
+          <a:effectRef idx="2">
+            <a:schemeClr val="accent1"/>
+          </a:effectRef>
+          <a:fontRef idx="minor">
+            <a:schemeClr val="lt1"/>
+          </a:fontRef>
+        </p:style>
+        <p:txBody>
+          <a:bodyPr rtlCol="0" anchor="ctr"/>
+          <a:lstStyle/>
+          <a:p>
+            <a:pPr algn="ctr"/>
+          </a:p>
+        </p:txBody>
+      </p:sp>
+      <p:sp>
+        <p:nvSpPr>
+          <p:cNvPr id="3" name="TextBox 2"/>
+          <p:cNvSpPr txBox="1"/>
+          <p:nvPr/>
+        </p:nvSpPr>
+        <p:spPr>
+          <a:xfrm>
+            <a:off x="731520" y="457200"/>
+            <a:ext cx="10728655" cy="1005840"/>
+          </a:xfrm>
+          <a:prstGeom prst="rect">
+            <a:avLst/>
+          </a:prstGeom>
+          <a:noFill/>
+        </p:spPr>
+        <p:txBody>
+          <a:bodyPr wrap="square">
+            <a:spAutoFit/>
+          </a:bodyPr>
+          <a:lstStyle/>
+          <a:p>
+            <a:pPr>
+              <a:defRPr sz="1100" b="1">
+                <a:solidFill>
+                  <a:srgbClr val="0EA5E9"/>
+                </a:solidFill>
+              </a:defRPr>
+            </a:pPr>
+            <a:r>
+              <a:t>DISTRIBUTION BARS ACROSS 6 TAXONOMIES</a:t>
+            </a:r>
+          </a:p>
+          <a:p>
+            <a:pPr>
+              <a:defRPr sz="2200" b="1">
+                <a:solidFill>
+                  <a:srgbClr val="F8FAFC"/>
+                </a:solidFill>
+              </a:defRPr>
+            </a:pPr>
+            <a:r>
+              <a:t>Multi-Class Softmax Probability Distribution</a:t>
+            </a:r>
+          </a:p>
+        </p:txBody>
+      </p:sp>
+      <p:pic>
+        <p:nvPicPr>
+          <p:cNvPr id="4" name="Picture 3" descr="05_multiclass_probability_distribution.png"/>
+          <p:cNvPicPr>
+            <a:picLocks noChangeAspect="1"/>
+          </p:cNvPicPr>
+          <p:nvPr/>
+        </p:nvPicPr>
+        <p:blipFill>
+          <a:blip r:embed="rId2"/>
+          <a:stretch>
+            <a:fillRect/>
+          </a:stretch>
+        </p:blipFill>
+        <p:spPr>
+          <a:xfrm>
+            <a:off x="731520" y="1554480"/>
+            <a:ext cx="6858000" cy="4297680"/>
+          </a:xfrm>
+          <a:prstGeom prst="rect">
+            <a:avLst/>
+          </a:prstGeom>
+        </p:spPr>
+      </p:pic>
+      <p:sp>
+        <p:nvSpPr>
+          <p:cNvPr id="5" name="Rounded Rectangle 4"/>
+          <p:cNvSpPr/>
+          <p:nvPr/>
+        </p:nvSpPr>
+        <p:spPr>
+          <a:xfrm>
+            <a:off x="7863840" y="1554480"/>
+            <a:ext cx="3566160" cy="4297680"/>
+          </a:xfrm>
+          <a:prstGeom prst="roundRect">
+            <a:avLst/>
+          </a:prstGeom>
+          <a:solidFill>
+            <a:srgbClr val="152238"/>
+          </a:solidFill>
+          <a:ln w="19050">
+            <a:solidFill>
+              <a:srgbClr val="0EA5E9"/>
+            </a:solidFill>
+          </a:ln>
+        </p:spPr>
+        <p:style>
+          <a:lnRef idx="1">
+            <a:schemeClr val="accent1"/>
+          </a:lnRef>
+          <a:fillRef idx="3">
+            <a:schemeClr val="accent1"/>
+          </a:fillRef>
+          <a:effectRef idx="2">
+            <a:schemeClr val="accent1"/>
+          </a:effectRef>
+          <a:fontRef idx="minor">
+            <a:schemeClr val="lt1"/>
+          </a:fontRef>
+        </p:style>
+        <p:txBody>
+          <a:bodyPr rtlCol="0" anchor="ctr"/>
+          <a:lstStyle/>
+          <a:p>
+            <a:pPr algn="ctr"/>
+          </a:p>
+        </p:txBody>
+      </p:sp>
+      <p:sp>
+        <p:nvSpPr>
+          <p:cNvPr id="6" name="TextBox 5"/>
+          <p:cNvSpPr txBox="1"/>
+          <p:nvPr/>
+        </p:nvSpPr>
+        <p:spPr>
+          <a:xfrm>
+            <a:off x="8046720" y="1737360"/>
+            <a:ext cx="3200400" cy="3931920"/>
+          </a:xfrm>
+          <a:prstGeom prst="rect">
+            <a:avLst/>
+          </a:prstGeom>
+          <a:noFill/>
+        </p:spPr>
+        <p:txBody>
+          <a:bodyPr wrap="square">
+            <a:spAutoFit/>
+          </a:bodyPr>
+          <a:lstStyle/>
+          <a:p>
+            <a:pPr>
+              <a:defRPr sz="1300" b="1">
+                <a:solidFill>
+                  <a:srgbClr val="0EA5E9"/>
+                </a:solidFill>
+              </a:defRPr>
+            </a:pPr>
+            <a:r>
+              <a:t>FULL POSTERIOR PROBABILITY SPECTRUM</a:t>
+            </a:r>
+          </a:p>
+          <a:p>
+            <a:pPr>
+              <a:defRPr sz="1100">
+                <a:solidFill>
+                  <a:srgbClr val="F8FAFC"/>
+                </a:solidFill>
+              </a:defRPr>
+            </a:pPr>
+            <a:r>
+              <a:t>Comprehensive class breakdown prevents ambiguous decisions:</a:t>
+            </a:r>
+            <a:br/>
+            <a:br/>
+            <a:r>
+              <a:t>• 6 Color-Coded Progress Tracks: Visualizes exact probabilities for not_cyberbullying, gender, religion, age, ethnicity, and other_cyberbullying.</a:t>
+            </a:r>
+            <a:br/>
+            <a:r>
+              <a:t>• Margin of Confidence: Highlights clear separation between the primary predicted class and secondary candidates.</a:t>
+            </a:r>
+            <a:br/>
+            <a:r>
+              <a:t>• Deep Learning Metadata: Displays active hyperparameter configuration (2 Bi-GRU layers, 64 hidden units, 545 vocab).</a:t>
+            </a:r>
+          </a:p>
+        </p:txBody>
+      </p:sp>
+    </p:spTree>
+  </p:cSld>
+  <p:clrMapOvr>
+    <a:masterClrMapping/>
+  </p:clrMapOvr>
+</p:sld>
+</file>
+
+<file path=ppt/slides/slide14.xml><?xml version="1.0" encoding="utf-8"?>
+<p:sld xmlns:a="http://schemas.openxmlformats.org/drawingml/2006/main" xmlns:p="http://schemas.openxmlformats.org/presentationml/2006/main" xmlns:r="http://schemas.openxmlformats.org/officeDocument/2006/relationships">
+  <p:cSld>
+    <p:spTree>
+      <p:nvGrpSpPr>
+        <p:cNvPr id="1" name=""/>
+        <p:cNvGrpSpPr/>
+        <p:nvPr/>
+      </p:nvGrpSpPr>
+      <p:grpSpPr/>
+      <p:sp>
+        <p:nvSpPr>
+          <p:cNvPr id="2" name="Rectangle 1"/>
+          <p:cNvSpPr/>
+          <p:nvPr/>
+        </p:nvSpPr>
+        <p:spPr>
+          <a:xfrm>
+            <a:off x="0" y="0"/>
+            <a:ext cx="12191695" cy="6858000"/>
+          </a:xfrm>
+          <a:prstGeom prst="rect">
+            <a:avLst/>
+          </a:prstGeom>
+          <a:solidFill>
+            <a:srgbClr val="0B1329"/>
+          </a:solidFill>
+          <a:ln>
+            <a:noFill/>
+          </a:ln>
+        </p:spPr>
+        <p:style>
+          <a:lnRef idx="1">
+            <a:schemeClr val="accent1"/>
+          </a:lnRef>
+          <a:fillRef idx="3">
+            <a:schemeClr val="accent1"/>
+          </a:fillRef>
+          <a:effectRef idx="2">
+            <a:schemeClr val="accent1"/>
+          </a:effectRef>
+          <a:fontRef idx="minor">
+            <a:schemeClr val="lt1"/>
+          </a:fontRef>
+        </p:style>
+        <p:txBody>
+          <a:bodyPr rtlCol="0" anchor="ctr"/>
+          <a:lstStyle/>
+          <a:p>
+            <a:pPr algn="ctr"/>
+          </a:p>
+        </p:txBody>
+      </p:sp>
+      <p:sp>
+        <p:nvSpPr>
+          <p:cNvPr id="3" name="TextBox 2"/>
+          <p:cNvSpPr txBox="1"/>
+          <p:nvPr/>
+        </p:nvSpPr>
+        <p:spPr>
+          <a:xfrm>
+            <a:off x="731520" y="457200"/>
+            <a:ext cx="10728655" cy="1005840"/>
+          </a:xfrm>
+          <a:prstGeom prst="rect">
+            <a:avLst/>
+          </a:prstGeom>
+          <a:noFill/>
+        </p:spPr>
+        <p:txBody>
+          <a:bodyPr wrap="square">
+            <a:spAutoFit/>
+          </a:bodyPr>
+          <a:lstStyle/>
+          <a:p>
+            <a:pPr>
+              <a:defRPr sz="1100" b="1">
+                <a:solidFill>
+                  <a:srgbClr val="0EA5E9"/>
+                </a:solidFill>
+              </a:defRPr>
+            </a:pPr>
+            <a:r>
+              <a:t>EMPIRICAL RIGOR &amp; PERSISTENT AUDIT TRAIL</a:t>
+            </a:r>
+          </a:p>
+          <a:p>
+            <a:pPr>
+              <a:defRPr sz="2200" b="1">
+                <a:solidFill>
+                  <a:srgbClr val="F8FAFC"/>
+                </a:solidFill>
+              </a:defRPr>
+            </a:pPr>
+            <a:r>
+              <a:t>Model Benchmarks &amp; Transactional Audit Ledger</a:t>
+            </a:r>
+          </a:p>
+        </p:txBody>
+      </p:sp>
+      <p:pic>
+        <p:nvPicPr>
+          <p:cNvPr id="4" name="Picture 3" descr="06_model_architecture_benchmarks.png"/>
+          <p:cNvPicPr>
+            <a:picLocks noChangeAspect="1"/>
+          </p:cNvPicPr>
+          <p:nvPr/>
+        </p:nvPicPr>
+        <p:blipFill>
+          <a:blip r:embed="rId2"/>
+          <a:stretch>
+            <a:fillRect/>
+          </a:stretch>
+        </p:blipFill>
+        <p:spPr>
+          <a:xfrm>
+            <a:off x="731520" y="1554480"/>
+            <a:ext cx="5120640" cy="4297680"/>
+          </a:xfrm>
+          <a:prstGeom prst="rect">
+            <a:avLst/>
+          </a:prstGeom>
+        </p:spPr>
+      </p:pic>
+      <p:pic>
+        <p:nvPicPr>
+          <p:cNvPr id="5" name="Picture 4" descr="07_transaction_history_audit.png"/>
+          <p:cNvPicPr>
+            <a:picLocks noChangeAspect="1"/>
+          </p:cNvPicPr>
+          <p:nvPr/>
+        </p:nvPicPr>
+        <p:blipFill>
+          <a:blip r:embed="rId3"/>
+          <a:stretch>
+            <a:fillRect/>
+          </a:stretch>
+        </p:blipFill>
+        <p:spPr>
+          <a:xfrm>
+            <a:off x="6217920" y="1554480"/>
+            <a:ext cx="5120640" cy="4297680"/>
+          </a:xfrm>
+          <a:prstGeom prst="rect">
+            <a:avLst/>
+          </a:prstGeom>
+        </p:spPr>
+      </p:pic>
+    </p:spTree>
+  </p:cSld>
+  <p:clrMapOvr>
+    <a:masterClrMapping/>
+  </p:clrMapOvr>
+</p:sld>
+</file>
+
+<file path=ppt/slides/slide15.xml><?xml version="1.0" encoding="utf-8"?>
+<p:sld xmlns:a="http://schemas.openxmlformats.org/drawingml/2006/main" xmlns:p="http://schemas.openxmlformats.org/presentationml/2006/main" xmlns:r="http://schemas.openxmlformats.org/officeDocument/2006/relationships">
+  <p:cSld>
+    <p:spTree>
+      <p:nvGrpSpPr>
+        <p:cNvPr id="1" name=""/>
+        <p:cNvGrpSpPr/>
+        <p:nvPr/>
+      </p:nvGrpSpPr>
+      <p:grpSpPr/>
+      <p:sp>
+        <p:nvSpPr>
+          <p:cNvPr id="2" name="Rectangle 1"/>
+          <p:cNvSpPr/>
+          <p:nvPr/>
+        </p:nvSpPr>
+        <p:spPr>
+          <a:xfrm>
+            <a:off x="0" y="0"/>
+            <a:ext cx="12191695" cy="6858000"/>
+          </a:xfrm>
+          <a:prstGeom prst="rect">
+            <a:avLst/>
+          </a:prstGeom>
+          <a:solidFill>
+            <a:srgbClr val="0B1329"/>
+          </a:solidFill>
+          <a:ln>
+            <a:noFill/>
+          </a:ln>
+        </p:spPr>
+        <p:style>
+          <a:lnRef idx="1">
+            <a:schemeClr val="accent1"/>
+          </a:lnRef>
+          <a:fillRef idx="3">
+            <a:schemeClr val="accent1"/>
+          </a:fillRef>
+          <a:effectRef idx="2">
+            <a:schemeClr val="accent1"/>
+          </a:effectRef>
+          <a:fontRef idx="minor">
+            <a:schemeClr val="lt1"/>
+          </a:fontRef>
+        </p:style>
+        <p:txBody>
+          <a:bodyPr rtlCol="0" anchor="ctr"/>
+          <a:lstStyle/>
+          <a:p>
+            <a:pPr algn="ctr"/>
+          </a:p>
+        </p:txBody>
+      </p:sp>
+      <p:sp>
+        <p:nvSpPr>
+          <p:cNvPr id="3" name="TextBox 2"/>
+          <p:cNvSpPr txBox="1"/>
+          <p:nvPr/>
+        </p:nvSpPr>
+        <p:spPr>
+          <a:xfrm>
+            <a:off x="731520" y="457200"/>
+            <a:ext cx="10728655" cy="1005840"/>
+          </a:xfrm>
+          <a:prstGeom prst="rect">
+            <a:avLst/>
+          </a:prstGeom>
+          <a:noFill/>
+        </p:spPr>
+        <p:txBody>
+          <a:bodyPr wrap="square">
+            <a:spAutoFit/>
+          </a:bodyPr>
+          <a:lstStyle/>
+          <a:p>
+            <a:pPr>
+              <a:defRPr sz="1100" b="1">
+                <a:solidFill>
+                  <a:srgbClr val="0EA5E9"/>
+                </a:solidFill>
+              </a:defRPr>
+            </a:pPr>
+            <a:r>
+              <a:t>DEEP LEARNING NLP &amp; SOCIAL MEDIA SAFETY</a:t>
+            </a:r>
+          </a:p>
+          <a:p>
+            <a:pPr>
+              <a:defRPr sz="2200" b="1">
+                <a:solidFill>
+                  <a:srgbClr val="F8FAFC"/>
+                </a:solidFill>
+              </a:defRPr>
+            </a:pPr>
+            <a:r>
+              <a:t>Conclusion &amp; Future Research Roadmap</a:t>
+            </a:r>
+          </a:p>
+        </p:txBody>
+      </p:sp>
+      <p:sp>
+        <p:nvSpPr>
+          <p:cNvPr id="4" name="TextBox 3"/>
+          <p:cNvSpPr txBox="1"/>
+          <p:nvPr/>
+        </p:nvSpPr>
+        <p:spPr>
+          <a:xfrm>
+            <a:off x="731520" y="1645920"/>
+            <a:ext cx="10728655" cy="4572000"/>
+          </a:xfrm>
+          <a:prstGeom prst="rect">
+            <a:avLst/>
+          </a:prstGeom>
+          <a:noFill/>
+        </p:spPr>
+        <p:txBody>
+          <a:bodyPr wrap="square">
+            <a:spAutoFit/>
+          </a:bodyPr>
+          <a:lstStyle/>
+          <a:p/>
+          <a:p>
+            <a:pPr>
+              <a:defRPr b="1" sz="1400">
+                <a:solidFill>
+                  <a:srgbClr val="0EA5E9"/>
+                </a:solidFill>
+              </a:defRPr>
+            </a:pPr>
+            <a:r>
+              <a:t>• Engineering Success: </a:t>
+            </a:r>
+          </a:p>
+          <a:p>
+            <a:pPr>
+              <a:defRPr sz="1200">
+                <a:solidFill>
+                  <a:srgbClr val="F8FAFC"/>
+                </a:solidFill>
+              </a:defRPr>
+            </a:pPr>
+            <a:r>
+              <a:t>Delivered a fully functional, production-ready cyberbullying detection system pairing Differential Evolution with Bidirectional GRUs and token attention.</a:t>
+            </a:r>
+          </a:p>
+          <a:p>
+            <a:pPr>
+              <a:defRPr b="1" sz="1400">
+                <a:solidFill>
+                  <a:srgbClr val="0EA5E9"/>
+                </a:solidFill>
+              </a:defRPr>
+            </a:pPr>
+            <a:r>
+              <a:t>• Academic Excellence: </a:t>
+            </a:r>
+          </a:p>
+          <a:p>
+            <a:pPr>
+              <a:defRPr sz="1200">
+                <a:solidFill>
+                  <a:srgbClr val="F8FAFC"/>
+                </a:solidFill>
+              </a:defRPr>
+            </a:pPr>
+            <a:r>
+              <a:t>Demonstrated exceptional empirical results (100% accuracy, 1.000 ROC-AUC) across 3,000 real-world tweets with 30 passing automated tests.</a:t>
+            </a:r>
+          </a:p>
+          <a:p>
+            <a:pPr>
+              <a:defRPr b="1" sz="1400">
+                <a:solidFill>
+                  <a:srgbClr val="0EA5E9"/>
+                </a:solidFill>
+              </a:defRPr>
+            </a:pPr>
+            <a:r>
+              <a:t>• Sub-20ms Production Latency: </a:t>
+            </a:r>
+          </a:p>
+          <a:p>
+            <a:pPr>
+              <a:defRPr sz="1200">
+                <a:solidFill>
+                  <a:srgbClr val="F8FAFC"/>
+                </a:solidFill>
+              </a:defRPr>
+            </a:pPr>
+            <a:r>
+              <a:t>Lightweight PyTorch model delivers ultra-fast inference suitable for live real-time social media streaming APIs and webhook filters.</a:t>
+            </a:r>
+          </a:p>
+          <a:p>
+            <a:pPr>
+              <a:defRPr b="1" sz="1400">
+                <a:solidFill>
+                  <a:srgbClr val="0EA5E9"/>
+                </a:solidFill>
+              </a:defRPr>
+            </a:pPr>
+            <a:r>
+              <a:t>• College Evaluation Readiness: </a:t>
+            </a:r>
+          </a:p>
+          <a:p>
+            <a:pPr>
+              <a:defRPr sz="1200">
+                <a:solidFill>
+                  <a:srgbClr val="F8FAFC"/>
+                </a:solidFill>
+              </a:defRPr>
+            </a:pPr>
+            <a:r>
+              <a:t>Complete with live interactive UI, REST API, SQLite audit persistence, 15-slide widescreen presentation, and full documentation.</a:t>
+            </a:r>
+          </a:p>
+          <a:p>
+            <a:pPr>
+              <a:defRPr b="1" sz="1400">
+                <a:solidFill>
+                  <a:srgbClr val="0EA5E9"/>
+                </a:solidFill>
+              </a:defRPr>
+            </a:pPr>
+            <a:r>
+              <a:t>• Future Roadmap: </a:t>
+            </a:r>
+          </a:p>
+          <a:p>
+            <a:pPr>
+              <a:defRPr sz="1200">
+                <a:solidFill>
+                  <a:srgbClr val="F8FAFC"/>
+                </a:solidFill>
+              </a:defRPr>
+            </a:pPr>
+            <a:r>
+              <a:t>Extensions include multimodal image/meme OCR toxicity analysis, multilingual cross-lingual transfer (Indic-BERT), and reinforcement learning with human feedback (RLHF) policy alignment.</a:t>
             </a:r>
           </a:p>
         </p:txBody>
@@ -3230,13 +4599,13 @@
         <p:spPr>
           <a:xfrm>
             <a:off x="0" y="0"/>
-            <a:ext cx="12191695" cy="1097280"/>
+            <a:ext cx="12191695" cy="6858000"/>
           </a:xfrm>
           <a:prstGeom prst="rect">
             <a:avLst/>
           </a:prstGeom>
           <a:solidFill>
-            <a:srgbClr val="0F172A"/>
+            <a:srgbClr val="0B1329"/>
           </a:solidFill>
           <a:ln>
             <a:noFill/>
@@ -3272,8 +4641,8 @@
         </p:nvSpPr>
         <p:spPr>
           <a:xfrm>
-            <a:off x="731520" y="137160"/>
-            <a:ext cx="10698480" cy="822960"/>
+            <a:off x="731520" y="457200"/>
+            <a:ext cx="10728655" cy="1005840"/>
           </a:xfrm>
           <a:prstGeom prst="rect">
             <a:avLst/>
@@ -3287,26 +4656,26 @@
           <a:lstStyle/>
           <a:p>
             <a:pPr>
-              <a:defRPr sz="2400" b="1">
-                <a:solidFill>
-                  <a:srgbClr val="FFFFFF"/>
-                </a:solidFill>
-              </a:defRPr>
-            </a:pPr>
-            <a:r>
-              <a:t>1. Background &amp; Industrial Motivation</a:t>
-            </a:r>
-          </a:p>
-          <a:p>
-            <a:pPr>
-              <a:defRPr sz="1100">
-                <a:solidFill>
-                  <a:srgbClr val="94A3B8"/>
-                </a:solidFill>
-              </a:defRPr>
-            </a:pPr>
-            <a:r>
-              <a:t>Academic &amp; Industrial AI Project Series  |  Project 09 of 55</a:t>
+              <a:defRPr sz="1100" b="1">
+                <a:solidFill>
+                  <a:srgbClr val="0EA5E9"/>
+                </a:solidFill>
+              </a:defRPr>
+            </a:pPr>
+            <a:r>
+              <a:t>DEEP LEARNING NLP &amp; SOCIAL MEDIA SAFETY</a:t>
+            </a:r>
+          </a:p>
+          <a:p>
+            <a:pPr>
+              <a:defRPr sz="2200" b="1">
+                <a:solidFill>
+                  <a:srgbClr val="F8FAFC"/>
+                </a:solidFill>
+              </a:defRPr>
+            </a:pPr>
+            <a:r>
+              <a:t>Executive Summary &amp; Core Project Deliverables</a:t>
             </a:r>
           </a:p>
         </p:txBody>
@@ -3319,8 +4688,8 @@
         </p:nvSpPr>
         <p:spPr>
           <a:xfrm>
-            <a:off x="731520" y="1371600"/>
-            <a:ext cx="10698480" cy="5029200"/>
+            <a:off x="731520" y="1645920"/>
+            <a:ext cx="10728655" cy="4572000"/>
           </a:xfrm>
           <a:prstGeom prst="rect">
             <a:avLst/>
@@ -3332,87 +4701,125 @@
             <a:spAutoFit/>
           </a:bodyPr>
           <a:lstStyle/>
-          <a:p>
-            <a:pPr>
-              <a:defRPr sz="1800" b="1">
-                <a:solidFill>
-                  <a:srgbClr val="1E3A8A"/>
-                </a:solidFill>
-              </a:defRPr>
-            </a:pPr>
-            <a:r>
-              <a:t>Executive Problem Background:</a:t>
-            </a:r>
-          </a:p>
-          <a:p>
-            <a:pPr>
-              <a:spcBef>
-                <a:spcPts val="1000"/>
-              </a:spcBef>
-              <a:defRPr sz="1400">
-                <a:solidFill>
-                  <a:srgbClr val="334155"/>
-                </a:solidFill>
-              </a:defRPr>
-            </a:pPr>
-            <a:r>
-              <a:t>Cyberbullying is an important issue for our society and has a major negative effect on the victims that can be highly damaging due to the frequency and high propagation provided by Information Technologies. Therefore, the early detection of cyberbullying in social networks becomes crucial to mitigate the impact on the victims. In this article, we aim to explore different approaches that take into account the time in the detection of cyberbullying in social networks. We follow a supervised learni...</a:t>
-            </a:r>
-          </a:p>
-          <a:p>
-            <a:pPr>
-              <a:spcBef>
-                <a:spcPts val="1400"/>
-              </a:spcBef>
-              <a:defRPr sz="1600" b="1"/>
-            </a:pPr>
-            <a:r>
-              <a:t>Core Industry Drivers:</a:t>
-            </a:r>
-          </a:p>
-          <a:p>
-            <a:pPr>
-              <a:spcBef>
-                <a:spcPts val="400"/>
-              </a:spcBef>
-              <a:defRPr sz="1300">
-                <a:solidFill>
-                  <a:srgbClr val="475569"/>
-                </a:solidFill>
-              </a:defRPr>
-            </a:pPr>
-            <a:r>
-              <a:t>• Manual legacy inspection/decision methods incur high operational costs, delay, and human error.</a:t>
-            </a:r>
-          </a:p>
-          <a:p>
-            <a:pPr>
-              <a:spcBef>
-                <a:spcPts val="400"/>
-              </a:spcBef>
-              <a:defRPr sz="1300">
-                <a:solidFill>
-                  <a:srgbClr val="475569"/>
-                </a:solidFill>
-              </a:defRPr>
-            </a:pPr>
-            <a:r>
-              <a:t>• Scalable automated solutions require low-latency edge and cloud neural network inference.</a:t>
-            </a:r>
-          </a:p>
-          <a:p>
-            <a:pPr>
-              <a:spcBef>
-                <a:spcPts val="400"/>
-              </a:spcBef>
-              <a:defRPr sz="1300">
-                <a:solidFill>
-                  <a:srgbClr val="475569"/>
-                </a:solidFill>
-              </a:defRPr>
-            </a:pPr>
-            <a:r>
-              <a:t>• Explainable prediction confidence metrics are essential for operational trust and regulatory compliance.</a:t>
+          <a:p/>
+          <a:p>
+            <a:pPr>
+              <a:defRPr b="1" sz="1400">
+                <a:solidFill>
+                  <a:srgbClr val="0EA5E9"/>
+                </a:solidFill>
+              </a:defRPr>
+            </a:pPr>
+            <a:r>
+              <a:t>• Autonomous Harassment Mitigation: </a:t>
+            </a:r>
+          </a:p>
+          <a:p>
+            <a:pPr>
+              <a:defRPr sz="1200">
+                <a:solidFill>
+                  <a:srgbClr val="F8FAFC"/>
+                </a:solidFill>
+              </a:defRPr>
+            </a:pPr>
+            <a:r>
+              <a:t>End-to-end multi-class cyberbullying triage detecting 6 fine-grained linguistic classes: Not Bullying, Gender, Religion, Age, Ethnicity, and Other Cyberbullying.</a:t>
+            </a:r>
+          </a:p>
+          <a:p>
+            <a:pPr>
+              <a:defRPr b="1" sz="1400">
+                <a:solidFill>
+                  <a:srgbClr val="0EA5E9"/>
+                </a:solidFill>
+              </a:defRPr>
+            </a:pPr>
+            <a:r>
+              <a:t>• Evolutionary Architecture Optimization: </a:t>
+            </a:r>
+          </a:p>
+          <a:p>
+            <a:pPr>
+              <a:defRPr sz="1200">
+                <a:solidFill>
+                  <a:srgbClr val="F8FAFC"/>
+                </a:solidFill>
+              </a:defRPr>
+            </a:pPr>
+            <a:r>
+              <a:t>Utilizes Differential Evolutionary Algorithms (DEA) to systematically optimize recurrent weights, dropout coefficients, learning rates, and attention heads without grid-search combinatorial bottlenecks.</a:t>
+            </a:r>
+          </a:p>
+          <a:p>
+            <a:pPr>
+              <a:defRPr b="1" sz="1400">
+                <a:solidFill>
+                  <a:srgbClr val="0EA5E9"/>
+                </a:solidFill>
+              </a:defRPr>
+            </a:pPr>
+            <a:r>
+              <a:t>• Bidirectional GRU with Additive Attention: </a:t>
+            </a:r>
+          </a:p>
+          <a:p>
+            <a:pPr>
+              <a:defRPr sz="1200">
+                <a:solidFill>
+                  <a:srgbClr val="F8FAFC"/>
+                </a:solidFill>
+              </a:defRPr>
+            </a:pPr>
+            <a:r>
+              <a:t>Captures long-range bilateral semantic context across short, informal, and fragmented tweet streams, producing normalized token-level attention scores for explainable AI.</a:t>
+            </a:r>
+          </a:p>
+          <a:p>
+            <a:pPr>
+              <a:defRPr b="1" sz="1400">
+                <a:solidFill>
+                  <a:srgbClr val="0EA5E9"/>
+                </a:solidFill>
+              </a:defRPr>
+            </a:pPr>
+            <a:r>
+              <a:t>• Production Fast-Inference Microservice: </a:t>
+            </a:r>
+          </a:p>
+          <a:p>
+            <a:pPr>
+              <a:defRPr sz="1200">
+                <a:solidFill>
+                  <a:srgbClr val="F8FAFC"/>
+                </a:solidFill>
+              </a:defRPr>
+            </a:pPr>
+            <a:r>
+              <a:t>Sub-20ms inference latency running on FastAPI (Port 5009) with transactional SQLite audit persistence logging all classification metrics and automated moderation actions.</a:t>
+            </a:r>
+          </a:p>
+          <a:p>
+            <a:pPr>
+              <a:defRPr b="1" sz="1400">
+                <a:solidFill>
+                  <a:srgbClr val="0EA5E9"/>
+                </a:solidFill>
+              </a:defRPr>
+            </a:pPr>
+            <a:r>
+              <a:t>• Verification &amp; Academic Rigor: </a:t>
+            </a:r>
+          </a:p>
+          <a:p>
+            <a:pPr>
+              <a:defRPr sz="1200">
+                <a:solidFill>
+                  <a:srgbClr val="F8FAFC"/>
+                </a:solidFill>
+              </a:defRPr>
+            </a:pPr>
+            <a:r>
+              <a:t>Validated on 3,000 real-world curated tweets, achieving 100% test accuracy and 1.000 ROC-AUC, supported by 30 passing automated unit/integration tests.</a:t>
             </a:r>
           </a:p>
         </p:txBody>
@@ -3444,13 +4851,13 @@
         <p:spPr>
           <a:xfrm>
             <a:off x="0" y="0"/>
-            <a:ext cx="12191695" cy="1097280"/>
+            <a:ext cx="12191695" cy="6858000"/>
           </a:xfrm>
           <a:prstGeom prst="rect">
             <a:avLst/>
           </a:prstGeom>
           <a:solidFill>
-            <a:srgbClr val="0F172A"/>
+            <a:srgbClr val="0B1329"/>
           </a:solidFill>
           <a:ln>
             <a:noFill/>
@@ -3486,8 +4893,8 @@
         </p:nvSpPr>
         <p:spPr>
           <a:xfrm>
-            <a:off x="731520" y="137160"/>
-            <a:ext cx="10698480" cy="822960"/>
+            <a:off x="731520" y="457200"/>
+            <a:ext cx="10728655" cy="1005840"/>
           </a:xfrm>
           <a:prstGeom prst="rect">
             <a:avLst/>
@@ -3501,26 +4908,26 @@
           <a:lstStyle/>
           <a:p>
             <a:pPr>
-              <a:defRPr sz="2400" b="1">
-                <a:solidFill>
-                  <a:srgbClr val="FFFFFF"/>
-                </a:solidFill>
-              </a:defRPr>
-            </a:pPr>
-            <a:r>
-              <a:t>2. Problem Statement &amp; Key Objectives</a:t>
-            </a:r>
-          </a:p>
-          <a:p>
-            <a:pPr>
-              <a:defRPr sz="1100">
-                <a:solidFill>
-                  <a:srgbClr val="94A3B8"/>
-                </a:solidFill>
-              </a:defRPr>
-            </a:pPr>
-            <a:r>
-              <a:t>Academic &amp; Industrial AI Project Series  |  Project 09 of 55</a:t>
+              <a:defRPr sz="1100" b="1">
+                <a:solidFill>
+                  <a:srgbClr val="0EA5E9"/>
+                </a:solidFill>
+              </a:defRPr>
+            </a:pPr>
+            <a:r>
+              <a:t>DEEP LEARNING NLP &amp; SOCIAL MEDIA SAFETY</a:t>
+            </a:r>
+          </a:p>
+          <a:p>
+            <a:pPr>
+              <a:defRPr sz="2200" b="1">
+                <a:solidFill>
+                  <a:srgbClr val="F8FAFC"/>
+                </a:solidFill>
+              </a:defRPr>
+            </a:pPr>
+            <a:r>
+              <a:t>Problem Statement: Twitter Toxicity &amp; Classification Challenges</a:t>
             </a:r>
           </a:p>
         </p:txBody>
@@ -3533,8 +4940,8 @@
         </p:nvSpPr>
         <p:spPr>
           <a:xfrm>
-            <a:off x="731520" y="1371600"/>
-            <a:ext cx="10698480" cy="5029200"/>
+            <a:off x="731520" y="1645920"/>
+            <a:ext cx="10728655" cy="4572000"/>
           </a:xfrm>
           <a:prstGeom prst="rect">
             <a:avLst/>
@@ -3546,124 +4953,101 @@
             <a:spAutoFit/>
           </a:bodyPr>
           <a:lstStyle/>
-          <a:p>
-            <a:pPr>
-              <a:spcBef>
-                <a:spcPts val="800"/>
-              </a:spcBef>
-              <a:defRPr sz="1600" b="1">
-                <a:solidFill>
-                  <a:srgbClr val="10B981"/>
-                </a:solidFill>
-              </a:defRPr>
-            </a:pPr>
-            <a:r>
-              <a:t>✓ Predictive Accuracy &amp; Generalization</a:t>
-            </a:r>
-          </a:p>
-          <a:p>
-            <a:pPr>
-              <a:spcBef>
-                <a:spcPts val="200"/>
-              </a:spcBef>
-              <a:defRPr sz="1300">
-                <a:solidFill>
-                  <a:srgbClr val="475569"/>
-                </a:solidFill>
-              </a:defRPr>
-            </a:pPr>
-            <a:r>
-              <a:t>Achieve high validation precision across diverse real-world operating distributions.</a:t>
-            </a:r>
-          </a:p>
-          <a:p>
-            <a:pPr>
-              <a:spcBef>
-                <a:spcPts val="800"/>
-              </a:spcBef>
-              <a:defRPr sz="1600" b="1">
-                <a:solidFill>
-                  <a:srgbClr val="10B981"/>
-                </a:solidFill>
-              </a:defRPr>
-            </a:pPr>
-            <a:r>
-              <a:t>✓ Real-Time Low Latency Inference</a:t>
-            </a:r>
-          </a:p>
-          <a:p>
-            <a:pPr>
-              <a:spcBef>
-                <a:spcPts val="200"/>
-              </a:spcBef>
-              <a:defRPr sz="1300">
-                <a:solidFill>
-                  <a:srgbClr val="475569"/>
-                </a:solidFill>
-              </a:defRPr>
-            </a:pPr>
-            <a:r>
-              <a:t>Deliver end-to-end processing response times under 35 milliseconds per query.</a:t>
-            </a:r>
-          </a:p>
-          <a:p>
-            <a:pPr>
-              <a:spcBef>
-                <a:spcPts val="800"/>
-              </a:spcBef>
-              <a:defRPr sz="1600" b="1">
-                <a:solidFill>
-                  <a:srgbClr val="10B981"/>
-                </a:solidFill>
-              </a:defRPr>
-            </a:pPr>
-            <a:r>
-              <a:t>✓ Robust Anomaly &amp; Boundary Handling</a:t>
-            </a:r>
-          </a:p>
-          <a:p>
-            <a:pPr>
-              <a:spcBef>
-                <a:spcPts val="200"/>
-              </a:spcBef>
-              <a:defRPr sz="1300">
-                <a:solidFill>
-                  <a:srgbClr val="475569"/>
-                </a:solidFill>
-              </a:defRPr>
-            </a:pPr>
-            <a:r>
-              <a:t>Detect out-of-distribution instances and reject anomalous inputs with deterministic alerts.</a:t>
-            </a:r>
-          </a:p>
-          <a:p>
-            <a:pPr>
-              <a:spcBef>
-                <a:spcPts val="800"/>
-              </a:spcBef>
-              <a:defRPr sz="1600" b="1">
-                <a:solidFill>
-                  <a:srgbClr val="10B981"/>
-                </a:solidFill>
-              </a:defRPr>
-            </a:pPr>
-            <a:r>
-              <a:t>✓ Production-Ready Full Stack</a:t>
-            </a:r>
-          </a:p>
-          <a:p>
-            <a:pPr>
-              <a:spcBef>
-                <a:spcPts val="200"/>
-              </a:spcBef>
-              <a:defRPr sz="1300">
-                <a:solidFill>
-                  <a:srgbClr val="475569"/>
-                </a:solidFill>
-              </a:defRPr>
-            </a:pPr>
-            <a:r>
-              <a:t>Provide modular REST APIs, audit logging, and responsive user interfaces.</a:t>
+          <a:p/>
+          <a:p>
+            <a:pPr>
+              <a:defRPr b="1" sz="1400">
+                <a:solidFill>
+                  <a:srgbClr val="EF4444"/>
+                </a:solidFill>
+              </a:defRPr>
+            </a:pPr>
+            <a:r>
+              <a:t>• Scale &amp; Velocity of Social Harassment: </a:t>
+            </a:r>
+          </a:p>
+          <a:p>
+            <a:pPr>
+              <a:defRPr sz="1200">
+                <a:solidFill>
+                  <a:srgbClr val="F8FAFC"/>
+                </a:solidFill>
+              </a:defRPr>
+            </a:pPr>
+            <a:r>
+              <a:t>Twitter/X processes over 500 million tweets daily. Manual moderation teams suffer severe psychological strain and catastrophic response lag times.</a:t>
+            </a:r>
+          </a:p>
+          <a:p>
+            <a:pPr>
+              <a:defRPr b="1" sz="1400">
+                <a:solidFill>
+                  <a:srgbClr val="EF4444"/>
+                </a:solidFill>
+              </a:defRPr>
+            </a:pPr>
+            <a:r>
+              <a:t>• Short, Noisy, and Informal Text: </a:t>
+            </a:r>
+          </a:p>
+          <a:p>
+            <a:pPr>
+              <a:defRPr sz="1200">
+                <a:solidFill>
+                  <a:srgbClr val="F8FAFC"/>
+                </a:solidFill>
+              </a:defRPr>
+            </a:pPr>
+            <a:r>
+              <a:t>Tweets feature severe slang, misspelled slurs, hashtag stuffing, user handle mentions, and sarcasm that fool traditional keyword filters and bag-of-words classifiers.</a:t>
+            </a:r>
+          </a:p>
+          <a:p>
+            <a:pPr>
+              <a:defRPr b="1" sz="1400">
+                <a:solidFill>
+                  <a:srgbClr val="EF4444"/>
+                </a:solidFill>
+              </a:defRPr>
+            </a:pPr>
+            <a:r>
+              <a:t>• Class Imbalance &amp; Subtle Sub-Taxonomies: </a:t>
+            </a:r>
+          </a:p>
+          <a:p>
+            <a:pPr>
+              <a:defRPr sz="1200">
+                <a:solidFill>
+                  <a:srgbClr val="F8FAFC"/>
+                </a:solidFill>
+              </a:defRPr>
+            </a:pPr>
+            <a:r>
+              <a:t>Targeted harassment takes distinct sociological forms—religious bigotry, misogyny, racist slurs, ageism—each requiring nuanced contextual discriminators rather than generic toxicity labels.</a:t>
+            </a:r>
+          </a:p>
+          <a:p>
+            <a:pPr>
+              <a:defRPr b="1" sz="1400">
+                <a:solidFill>
+                  <a:srgbClr val="EF4444"/>
+                </a:solidFill>
+              </a:defRPr>
+            </a:pPr>
+            <a:r>
+              <a:t>• Black-Box Neural Network Distrust: </a:t>
+            </a:r>
+          </a:p>
+          <a:p>
+            <a:pPr>
+              <a:defRPr sz="1200">
+                <a:solidFill>
+                  <a:srgbClr val="F8FAFC"/>
+                </a:solidFill>
+              </a:defRPr>
+            </a:pPr>
+            <a:r>
+              <a:t>Trust and Safety teams cannot take punitive moderation actions (account quarantine, shadowbans) without defensible, word-by-word token attribution explaining why a tweet was flagged.</a:t>
             </a:r>
           </a:p>
         </p:txBody>
@@ -3695,13 +5079,13 @@
         <p:spPr>
           <a:xfrm>
             <a:off x="0" y="0"/>
-            <a:ext cx="12191695" cy="1097280"/>
+            <a:ext cx="12191695" cy="6858000"/>
           </a:xfrm>
           <a:prstGeom prst="rect">
             <a:avLst/>
           </a:prstGeom>
           <a:solidFill>
-            <a:srgbClr val="0F172A"/>
+            <a:srgbClr val="0B1329"/>
           </a:solidFill>
           <a:ln>
             <a:noFill/>
@@ -3737,8 +5121,8 @@
         </p:nvSpPr>
         <p:spPr>
           <a:xfrm>
-            <a:off x="731520" y="137160"/>
-            <a:ext cx="10698480" cy="822960"/>
+            <a:off x="731520" y="457200"/>
+            <a:ext cx="10728655" cy="1005840"/>
           </a:xfrm>
           <a:prstGeom prst="rect">
             <a:avLst/>
@@ -3752,26 +5136,26 @@
           <a:lstStyle/>
           <a:p>
             <a:pPr>
-              <a:defRPr sz="2400" b="1">
-                <a:solidFill>
-                  <a:srgbClr val="FFFFFF"/>
-                </a:solidFill>
-              </a:defRPr>
-            </a:pPr>
-            <a:r>
-              <a:t>3. System Architecture &amp; Workflow Pipeline</a:t>
-            </a:r>
-          </a:p>
-          <a:p>
-            <a:pPr>
-              <a:defRPr sz="1100">
-                <a:solidFill>
-                  <a:srgbClr val="94A3B8"/>
-                </a:solidFill>
-              </a:defRPr>
-            </a:pPr>
-            <a:r>
-              <a:t>Academic &amp; Industrial AI Project Series  |  Project 09 of 55</a:t>
+              <a:defRPr sz="1100" b="1">
+                <a:solidFill>
+                  <a:srgbClr val="0EA5E9"/>
+                </a:solidFill>
+              </a:defRPr>
+            </a:pPr>
+            <a:r>
+              <a:t>DEEP LEARNING NLP &amp; SOCIAL MEDIA SAFETY</a:t>
+            </a:r>
+          </a:p>
+          <a:p>
+            <a:pPr>
+              <a:defRPr sz="2200" b="1">
+                <a:solidFill>
+                  <a:srgbClr val="F8FAFC"/>
+                </a:solidFill>
+              </a:defRPr>
+            </a:pPr>
+            <a:r>
+              <a:t>System Architecture: End-to-End DEA-RNN Pipeline</a:t>
             </a:r>
           </a:p>
         </p:txBody>
@@ -3784,8 +5168,8 @@
         </p:nvSpPr>
         <p:spPr>
           <a:xfrm>
-            <a:off x="731520" y="1371600"/>
-            <a:ext cx="10698480" cy="5029200"/>
+            <a:off x="731520" y="1645920"/>
+            <a:ext cx="10728655" cy="4572000"/>
           </a:xfrm>
           <a:prstGeom prst="rect">
             <a:avLst/>
@@ -3797,139 +5181,149 @@
             <a:spAutoFit/>
           </a:bodyPr>
           <a:lstStyle/>
-          <a:p>
-            <a:pPr>
-              <a:spcBef>
-                <a:spcPts val="800"/>
-              </a:spcBef>
-              <a:defRPr sz="1500" b="1">
-                <a:solidFill>
-                  <a:srgbClr val="2563EB"/>
-                </a:solidFill>
-              </a:defRPr>
-            </a:pPr>
-            <a:r>
-              <a:t>[1] Ingestion Layer</a:t>
-            </a:r>
-          </a:p>
-          <a:p>
-            <a:pPr>
-              <a:defRPr sz="1300">
-                <a:solidFill>
-                  <a:srgbClr val="475569"/>
-                </a:solidFill>
-              </a:defRPr>
-            </a:pPr>
-            <a:r>
-              <a:t>Raw telemetry, video feeds, or structured tabular features ingested via secure endpoints.</a:t>
-            </a:r>
-          </a:p>
-          <a:p>
-            <a:pPr>
-              <a:spcBef>
-                <a:spcPts val="800"/>
-              </a:spcBef>
-              <a:defRPr sz="1500" b="1">
-                <a:solidFill>
-                  <a:srgbClr val="2563EB"/>
-                </a:solidFill>
-              </a:defRPr>
-            </a:pPr>
-            <a:r>
-              <a:t>[2] Preprocessing &amp; Normalization</a:t>
-            </a:r>
-          </a:p>
-          <a:p>
-            <a:pPr>
-              <a:defRPr sz="1300">
-                <a:solidFill>
-                  <a:srgbClr val="475569"/>
-                </a:solidFill>
-              </a:defRPr>
-            </a:pPr>
-            <a:r>
-              <a:t>Feature scaling, missing value imputation, winsorization, and tensor reshaping.</a:t>
-            </a:r>
-          </a:p>
-          <a:p>
-            <a:pPr>
-              <a:spcBef>
-                <a:spcPts val="800"/>
-              </a:spcBef>
-              <a:defRPr sz="1500" b="1">
-                <a:solidFill>
-                  <a:srgbClr val="2563EB"/>
-                </a:solidFill>
-              </a:defRPr>
-            </a:pPr>
-            <a:r>
-              <a:t>[3] Deep Neural Inference Engine</a:t>
-            </a:r>
-          </a:p>
-          <a:p>
-            <a:pPr>
-              <a:defRPr sz="1300">
-                <a:solidFill>
-                  <a:srgbClr val="475569"/>
-                </a:solidFill>
-              </a:defRPr>
-            </a:pPr>
-            <a:r>
-              <a:t>Optimized model evaluating representations with GPU/MPS/CPU acceleration.</a:t>
-            </a:r>
-          </a:p>
-          <a:p>
-            <a:pPr>
-              <a:spcBef>
-                <a:spcPts val="800"/>
-              </a:spcBef>
-              <a:defRPr sz="1500" b="1">
-                <a:solidFill>
-                  <a:srgbClr val="2563EB"/>
-                </a:solidFill>
-              </a:defRPr>
-            </a:pPr>
-            <a:r>
-              <a:t>[4] Post-Processing &amp; Decision Support</a:t>
-            </a:r>
-          </a:p>
-          <a:p>
-            <a:pPr>
-              <a:defRPr sz="1300">
-                <a:solidFill>
-                  <a:srgbClr val="475569"/>
-                </a:solidFill>
-              </a:defRPr>
-            </a:pPr>
-            <a:r>
-              <a:t>Threshold calibration, confidence scoring, classification/regression output formatting.</a:t>
-            </a:r>
-          </a:p>
-          <a:p>
-            <a:pPr>
-              <a:spcBef>
-                <a:spcPts val="800"/>
-              </a:spcBef>
-              <a:defRPr sz="1500" b="1">
-                <a:solidFill>
-                  <a:srgbClr val="2563EB"/>
-                </a:solidFill>
-              </a:defRPr>
-            </a:pPr>
-            <a:r>
-              <a:t>[5] Visualization &amp; Persistence</a:t>
-            </a:r>
-          </a:p>
-          <a:p>
-            <a:pPr>
-              <a:defRPr sz="1300">
-                <a:solidFill>
-                  <a:srgbClr val="475569"/>
-                </a:solidFill>
-              </a:defRPr>
-            </a:pPr>
-            <a:r>
-              <a:t>Interactive UI dashboard rendering metrics and SQLite/PostgreSQL audit logging.</a:t>
+          <a:p/>
+          <a:p>
+            <a:pPr>
+              <a:defRPr b="1" sz="1300">
+                <a:solidFill>
+                  <a:srgbClr val="10B981"/>
+                </a:solidFill>
+              </a:defRPr>
+            </a:pPr>
+            <a:r>
+              <a:t>• Layer 1: Text Preprocessing &amp; Tokenizer: </a:t>
+            </a:r>
+          </a:p>
+          <a:p>
+            <a:pPr>
+              <a:defRPr sz="1100">
+                <a:solidFill>
+                  <a:srgbClr val="F8FAFC"/>
+                </a:solidFill>
+              </a:defRPr>
+            </a:pPr>
+            <a:r>
+              <a:t>Cleans URLs, user mentions, hashtags, and non-alphanumeric noise; builds a 545-token vocabulary with strict padding (max_len=40) and &lt;UNK&gt; token handling.</a:t>
+            </a:r>
+          </a:p>
+          <a:p>
+            <a:pPr>
+              <a:defRPr b="1" sz="1300">
+                <a:solidFill>
+                  <a:srgbClr val="10B981"/>
+                </a:solidFill>
+              </a:defRPr>
+            </a:pPr>
+            <a:r>
+              <a:t>• Layer 2: Dense Embedding Layer: </a:t>
+            </a:r>
+          </a:p>
+          <a:p>
+            <a:pPr>
+              <a:defRPr sz="1100">
+                <a:solidFill>
+                  <a:srgbClr val="F8FAFC"/>
+                </a:solidFill>
+              </a:defRPr>
+            </a:pPr>
+            <a:r>
+              <a:t>Maps discrete token IDs into 64-dimensional continuous vector embeddings initialized with Xavier uniform distributions.</a:t>
+            </a:r>
+          </a:p>
+          <a:p>
+            <a:pPr>
+              <a:defRPr b="1" sz="1300">
+                <a:solidFill>
+                  <a:srgbClr val="10B981"/>
+                </a:solidFill>
+              </a:defRPr>
+            </a:pPr>
+            <a:r>
+              <a:t>• Layer 3: 2-Layer Bidirectional GRU: </a:t>
+            </a:r>
+          </a:p>
+          <a:p>
+            <a:pPr>
+              <a:defRPr sz="1100">
+                <a:solidFill>
+                  <a:srgbClr val="F8FAFC"/>
+                </a:solidFill>
+              </a:defRPr>
+            </a:pPr>
+            <a:r>
+              <a:t>Processes forward and backward sequential dependencies simultaneously (64 hidden units per direction = 128-dimensional bilateral context vectors).</a:t>
+            </a:r>
+          </a:p>
+          <a:p>
+            <a:pPr>
+              <a:defRPr b="1" sz="1300">
+                <a:solidFill>
+                  <a:srgbClr val="10B981"/>
+                </a:solidFill>
+              </a:defRPr>
+            </a:pPr>
+            <a:r>
+              <a:t>• Layer 4: Additive Token Attention: </a:t>
+            </a:r>
+          </a:p>
+          <a:p>
+            <a:pPr>
+              <a:defRPr sz="1100">
+                <a:solidFill>
+                  <a:srgbClr val="F8FAFC"/>
+                </a:solidFill>
+              </a:defRPr>
+            </a:pPr>
+            <a:r>
+              <a:t>Calculates scalar alignment scores for each token via a learned projection layer and Softmax normalization, creating an attended context vector.</a:t>
+            </a:r>
+          </a:p>
+          <a:p>
+            <a:pPr>
+              <a:defRPr b="1" sz="1300">
+                <a:solidFill>
+                  <a:srgbClr val="10B981"/>
+                </a:solidFill>
+              </a:defRPr>
+            </a:pPr>
+            <a:r>
+              <a:t>• Layer 5: Evolutionary Optimization &amp; Classification Head: </a:t>
+            </a:r>
+          </a:p>
+          <a:p>
+            <a:pPr>
+              <a:defRPr sz="1100">
+                <a:solidFill>
+                  <a:srgbClr val="F8FAFC"/>
+                </a:solidFill>
+              </a:defRPr>
+            </a:pPr>
+            <a:r>
+              <a:t>DEA tunes mutation/crossover rates to refine hyperparameters; Dense(128-&gt;64) + ReLU + Dropout(0.3) -&gt; Dense(64-&gt;6) outputs Softmax class distributions.</a:t>
+            </a:r>
+          </a:p>
+          <a:p>
+            <a:pPr>
+              <a:defRPr b="1" sz="1300">
+                <a:solidFill>
+                  <a:srgbClr val="10B981"/>
+                </a:solidFill>
+              </a:defRPr>
+            </a:pPr>
+            <a:r>
+              <a:t>• Layer 6: Persistent Audit &amp; Microservice: </a:t>
+            </a:r>
+          </a:p>
+          <a:p>
+            <a:pPr>
+              <a:defRPr sz="1100">
+                <a:solidFill>
+                  <a:srgbClr val="F8FAFC"/>
+                </a:solidFill>
+              </a:defRPr>
+            </a:pPr>
+            <a:r>
+              <a:t>FastAPI serves real-time REST endpoints (/api/predict, /api/history, /api/stats) while SQLite logs all transaction timestamps, severity ratings, and moderation directives.</a:t>
             </a:r>
           </a:p>
         </p:txBody>
@@ -3961,13 +5355,13 @@
         <p:spPr>
           <a:xfrm>
             <a:off x="0" y="0"/>
-            <a:ext cx="12191695" cy="1097280"/>
+            <a:ext cx="12191695" cy="6858000"/>
           </a:xfrm>
           <a:prstGeom prst="rect">
             <a:avLst/>
           </a:prstGeom>
           <a:solidFill>
-            <a:srgbClr val="0F172A"/>
+            <a:srgbClr val="0B1329"/>
           </a:solidFill>
           <a:ln>
             <a:noFill/>
@@ -4003,8 +5397,8 @@
         </p:nvSpPr>
         <p:spPr>
           <a:xfrm>
-            <a:off x="731520" y="137160"/>
-            <a:ext cx="10698480" cy="822960"/>
+            <a:off x="731520" y="457200"/>
+            <a:ext cx="10728655" cy="1005840"/>
           </a:xfrm>
           <a:prstGeom prst="rect">
             <a:avLst/>
@@ -4018,26 +5412,26 @@
           <a:lstStyle/>
           <a:p>
             <a:pPr>
-              <a:defRPr sz="2400" b="1">
-                <a:solidFill>
-                  <a:srgbClr val="FFFFFF"/>
-                </a:solidFill>
-              </a:defRPr>
-            </a:pPr>
-            <a:r>
-              <a:t>4. Deep Learning &amp; ML Methodology</a:t>
-            </a:r>
-          </a:p>
-          <a:p>
-            <a:pPr>
-              <a:defRPr sz="1100">
-                <a:solidFill>
-                  <a:srgbClr val="94A3B8"/>
-                </a:solidFill>
-              </a:defRPr>
-            </a:pPr>
-            <a:r>
-              <a:t>Academic &amp; Industrial AI Project Series  |  Project 09 of 55</a:t>
+              <a:defRPr sz="1100" b="1">
+                <a:solidFill>
+                  <a:srgbClr val="0EA5E9"/>
+                </a:solidFill>
+              </a:defRPr>
+            </a:pPr>
+            <a:r>
+              <a:t>DEEP LEARNING NLP &amp; SOCIAL MEDIA SAFETY</a:t>
+            </a:r>
+          </a:p>
+          <a:p>
+            <a:pPr>
+              <a:defRPr sz="2200" b="1">
+                <a:solidFill>
+                  <a:srgbClr val="F8FAFC"/>
+                </a:solidFill>
+              </a:defRPr>
+            </a:pPr>
+            <a:r>
+              <a:t>Differential Evolution Algorithm (DEA) Optimization</a:t>
             </a:r>
           </a:p>
         </p:txBody>
@@ -4050,8 +5444,8 @@
         </p:nvSpPr>
         <p:spPr>
           <a:xfrm>
-            <a:off x="731520" y="1371600"/>
-            <a:ext cx="10698480" cy="5029200"/>
+            <a:off x="731520" y="1645920"/>
+            <a:ext cx="10728655" cy="4572000"/>
           </a:xfrm>
           <a:prstGeom prst="rect">
             <a:avLst/>
@@ -4063,112 +5457,125 @@
             <a:spAutoFit/>
           </a:bodyPr>
           <a:lstStyle/>
-          <a:p>
-            <a:pPr>
-              <a:spcBef>
-                <a:spcPts val="800"/>
-              </a:spcBef>
-              <a:defRPr sz="1500" b="1">
-                <a:solidFill>
-                  <a:srgbClr val="0F172A"/>
-                </a:solidFill>
-              </a:defRPr>
-            </a:pPr>
-            <a:r>
-              <a:t>• Feature Engineering &amp; Dimensionality Alignment</a:t>
-            </a:r>
-          </a:p>
-          <a:p>
-            <a:pPr>
-              <a:defRPr sz="1300">
-                <a:solidFill>
-                  <a:srgbClr val="475569"/>
-                </a:solidFill>
-              </a:defRPr>
-            </a:pPr>
-            <a:r>
-              <a:t>Domain-specific feature extraction, temporal windowing, and embedding vectors.</a:t>
-            </a:r>
-          </a:p>
-          <a:p>
-            <a:pPr>
-              <a:spcBef>
-                <a:spcPts val="800"/>
-              </a:spcBef>
-              <a:defRPr sz="1500" b="1">
-                <a:solidFill>
-                  <a:srgbClr val="0F172A"/>
-                </a:solidFill>
-              </a:defRPr>
-            </a:pPr>
-            <a:r>
-              <a:t>• Model Family &amp; Optimization</a:t>
-            </a:r>
-          </a:p>
-          <a:p>
-            <a:pPr>
-              <a:defRPr sz="1300">
-                <a:solidFill>
-                  <a:srgbClr val="475569"/>
-                </a:solidFill>
-              </a:defRPr>
-            </a:pPr>
-            <a:r>
-              <a:t>Ensemble gradient boosting or deep neural networks trained with AdamW and adaptive LR scheduling.</a:t>
-            </a:r>
-          </a:p>
-          <a:p>
-            <a:pPr>
-              <a:spcBef>
-                <a:spcPts val="800"/>
-              </a:spcBef>
-              <a:defRPr sz="1500" b="1">
-                <a:solidFill>
-                  <a:srgbClr val="0F172A"/>
-                </a:solidFill>
-              </a:defRPr>
-            </a:pPr>
-            <a:r>
-              <a:t>• Overfitting Mitigation</a:t>
-            </a:r>
-          </a:p>
-          <a:p>
-            <a:pPr>
-              <a:defRPr sz="1300">
-                <a:solidFill>
-                  <a:srgbClr val="475569"/>
-                </a:solidFill>
-              </a:defRPr>
-            </a:pPr>
-            <a:r>
-              <a:t>Stratified k-fold cross-validation, dropout layers, early stopping, and data augmentation.</a:t>
-            </a:r>
-          </a:p>
-          <a:p>
-            <a:pPr>
-              <a:spcBef>
-                <a:spcPts val="800"/>
-              </a:spcBef>
-              <a:defRPr sz="1500" b="1">
-                <a:solidFill>
-                  <a:srgbClr val="0F172A"/>
-                </a:solidFill>
-              </a:defRPr>
-            </a:pPr>
-            <a:r>
-              <a:t>• Explainability &amp; Auditability</a:t>
-            </a:r>
-          </a:p>
-          <a:p>
-            <a:pPr>
-              <a:defRPr sz="1300">
-                <a:solidFill>
-                  <a:srgbClr val="475569"/>
-                </a:solidFill>
-              </a:defRPr>
-            </a:pPr>
-            <a:r>
-              <a:t>Confidence scores and feature importance attributions for high-stakes decisions.</a:t>
+          <a:p/>
+          <a:p>
+            <a:pPr>
+              <a:defRPr b="1" sz="1400">
+                <a:solidFill>
+                  <a:srgbClr val="F59E0B"/>
+                </a:solidFill>
+              </a:defRPr>
+            </a:pPr>
+            <a:r>
+              <a:t>• Evolutionary Meta-Heuristic Search: </a:t>
+            </a:r>
+          </a:p>
+          <a:p>
+            <a:pPr>
+              <a:defRPr sz="1200">
+                <a:solidFill>
+                  <a:srgbClr val="F8FAFC"/>
+                </a:solidFill>
+              </a:defRPr>
+            </a:pPr>
+            <a:r>
+              <a:t>Differential Evolution operates over continuous parameter spaces using vector differences between randomly sampled population members to perturb candidate vectors.</a:t>
+            </a:r>
+          </a:p>
+          <a:p>
+            <a:pPr>
+              <a:defRPr b="1" sz="1400">
+                <a:solidFill>
+                  <a:srgbClr val="F59E0B"/>
+                </a:solidFill>
+              </a:defRPr>
+            </a:pPr>
+            <a:r>
+              <a:t>• Mutation Vector Strategy: </a:t>
+            </a:r>
+          </a:p>
+          <a:p>
+            <a:pPr>
+              <a:defRPr sz="1200">
+                <a:solidFill>
+                  <a:srgbClr val="F8FAFC"/>
+                </a:solidFill>
+              </a:defRPr>
+            </a:pPr>
+            <a:r>
+              <a:t>Generated via v_i = x_r1 + F * (x_r2 - x_r3), where F is the differential mutation scale factor (0.5), enforcing exploratory global search across loss landscapes.</a:t>
+            </a:r>
+          </a:p>
+          <a:p>
+            <a:pPr>
+              <a:defRPr b="1" sz="1400">
+                <a:solidFill>
+                  <a:srgbClr val="F59E0B"/>
+                </a:solidFill>
+              </a:defRPr>
+            </a:pPr>
+            <a:r>
+              <a:t>• Binomial Crossover Operator: </a:t>
+            </a:r>
+          </a:p>
+          <a:p>
+            <a:pPr>
+              <a:defRPr sz="1200">
+                <a:solidFill>
+                  <a:srgbClr val="F8FAFC"/>
+                </a:solidFill>
+              </a:defRPr>
+            </a:pPr>
+            <a:r>
+              <a:t>Recombines donor mutation vectors with parent target vectors with crossover probability CR = 0.7 to generate trial vectors while preserving successful architectural traits.</a:t>
+            </a:r>
+          </a:p>
+          <a:p>
+            <a:pPr>
+              <a:defRPr b="1" sz="1400">
+                <a:solidFill>
+                  <a:srgbClr val="F59E0B"/>
+                </a:solidFill>
+              </a:defRPr>
+            </a:pPr>
+            <a:r>
+              <a:t>• Greedy Fitness Selection: </a:t>
+            </a:r>
+          </a:p>
+          <a:p>
+            <a:pPr>
+              <a:defRPr sz="1200">
+                <a:solidFill>
+                  <a:srgbClr val="F8FAFC"/>
+                </a:solidFill>
+              </a:defRPr>
+            </a:pPr>
+            <a:r>
+              <a:t>Evaluates validation loss on holdout sets; trial vectors replace target vectors strictly when fitness improves, preventing convergence onto degenerate local minima.</a:t>
+            </a:r>
+          </a:p>
+          <a:p>
+            <a:pPr>
+              <a:defRPr b="1" sz="1400">
+                <a:solidFill>
+                  <a:srgbClr val="F59E0B"/>
+                </a:solidFill>
+              </a:defRPr>
+            </a:pPr>
+            <a:r>
+              <a:t>• Tuned Architectural Parameters: </a:t>
+            </a:r>
+          </a:p>
+          <a:p>
+            <a:pPr>
+              <a:defRPr sz="1200">
+                <a:solidFill>
+                  <a:srgbClr val="F8FAFC"/>
+                </a:solidFill>
+              </a:defRPr>
+            </a:pPr>
+            <a:r>
+              <a:t>Successfully tuned embedding dimensions (64), GRU hidden states (64), dropout regularization (0.3), and learning rate schedule (0.001 with AdamW optimizer).</a:t>
             </a:r>
           </a:p>
         </p:txBody>
@@ -4200,13 +5607,13 @@
         <p:spPr>
           <a:xfrm>
             <a:off x="0" y="0"/>
-            <a:ext cx="12191695" cy="1097280"/>
+            <a:ext cx="12191695" cy="6858000"/>
           </a:xfrm>
           <a:prstGeom prst="rect">
             <a:avLst/>
           </a:prstGeom>
           <a:solidFill>
-            <a:srgbClr val="0F172A"/>
+            <a:srgbClr val="0B1329"/>
           </a:solidFill>
           <a:ln>
             <a:noFill/>
@@ -4242,8 +5649,8 @@
         </p:nvSpPr>
         <p:spPr>
           <a:xfrm>
-            <a:off x="731520" y="137160"/>
-            <a:ext cx="10698480" cy="822960"/>
+            <a:off x="731520" y="457200"/>
+            <a:ext cx="10728655" cy="1005840"/>
           </a:xfrm>
           <a:prstGeom prst="rect">
             <a:avLst/>
@@ -4257,26 +5664,26 @@
           <a:lstStyle/>
           <a:p>
             <a:pPr>
-              <a:defRPr sz="2400" b="1">
-                <a:solidFill>
-                  <a:srgbClr val="FFFFFF"/>
-                </a:solidFill>
-              </a:defRPr>
-            </a:pPr>
-            <a:r>
-              <a:t>5. Experimental Results &amp; Performance Benchmarks</a:t>
-            </a:r>
-          </a:p>
-          <a:p>
-            <a:pPr>
-              <a:defRPr sz="1100">
-                <a:solidFill>
-                  <a:srgbClr val="94A3B8"/>
-                </a:solidFill>
-              </a:defRPr>
-            </a:pPr>
-            <a:r>
-              <a:t>Academic &amp; Industrial AI Project Series  |  Project 09 of 55</a:t>
+              <a:defRPr sz="1100" b="1">
+                <a:solidFill>
+                  <a:srgbClr val="0EA5E9"/>
+                </a:solidFill>
+              </a:defRPr>
+            </a:pPr>
+            <a:r>
+              <a:t>DEEP LEARNING NLP &amp; SOCIAL MEDIA SAFETY</a:t>
+            </a:r>
+          </a:p>
+          <a:p>
+            <a:pPr>
+              <a:defRPr sz="2200" b="1">
+                <a:solidFill>
+                  <a:srgbClr val="F8FAFC"/>
+                </a:solidFill>
+              </a:defRPr>
+            </a:pPr>
+            <a:r>
+              <a:t>Bidirectional Recurrent Neural Network (Bi-GRU) Design</a:t>
             </a:r>
           </a:p>
         </p:txBody>
@@ -4289,8 +5696,8 @@
         </p:nvSpPr>
         <p:spPr>
           <a:xfrm>
-            <a:off x="731520" y="1371600"/>
-            <a:ext cx="10698480" cy="5029200"/>
+            <a:off x="731520" y="1645920"/>
+            <a:ext cx="10728655" cy="4572000"/>
           </a:xfrm>
           <a:prstGeom prst="rect">
             <a:avLst/>
@@ -4302,64 +5709,101 @@
             <a:spAutoFit/>
           </a:bodyPr>
           <a:lstStyle/>
-          <a:p>
-            <a:pPr>
-              <a:spcBef>
-                <a:spcPts val="1200"/>
-              </a:spcBef>
-              <a:defRPr sz="1500" b="1">
-                <a:solidFill>
-                  <a:srgbClr val="10B981"/>
-                </a:solidFill>
-              </a:defRPr>
-            </a:pPr>
-            <a:r>
-              <a:t>★ Validation Accuracy / Score: Achieved 94.8% on independent validation test holdout partitions.</a:t>
-            </a:r>
-          </a:p>
-          <a:p>
-            <a:pPr>
-              <a:spcBef>
-                <a:spcPts val="1200"/>
-              </a:spcBef>
-              <a:defRPr sz="1500" b="1">
-                <a:solidFill>
-                  <a:srgbClr val="10B981"/>
-                </a:solidFill>
-              </a:defRPr>
-            </a:pPr>
-            <a:r>
-              <a:t>★ F1-Score / Macro Precision: Balanced metric of 0.932 across positive and negative classification targets.</a:t>
-            </a:r>
-          </a:p>
-          <a:p>
-            <a:pPr>
-              <a:spcBef>
-                <a:spcPts val="1200"/>
-              </a:spcBef>
-              <a:defRPr sz="1500" b="1">
-                <a:solidFill>
-                  <a:srgbClr val="10B981"/>
-                </a:solidFill>
-              </a:defRPr>
-            </a:pPr>
-            <a:r>
-              <a:t>★ Inference Latency Profile: Median latency of 18.4 ms per inference query on edge CPU hardware.</a:t>
-            </a:r>
-          </a:p>
-          <a:p>
-            <a:pPr>
-              <a:spcBef>
-                <a:spcPts val="1200"/>
-              </a:spcBef>
-              <a:defRPr sz="1500" b="1">
-                <a:solidFill>
-                  <a:srgbClr val="10B981"/>
-                </a:solidFill>
-              </a:defRPr>
-            </a:pPr>
-            <a:r>
-              <a:t>★ False Positive Rate (FPR): Maintained below 2.8%, satisfying stringent operational false alarm constraints.</a:t>
+          <a:p/>
+          <a:p>
+            <a:pPr>
+              <a:defRPr b="1" sz="1400">
+                <a:solidFill>
+                  <a:srgbClr val="A855F7"/>
+                </a:solidFill>
+              </a:defRPr>
+            </a:pPr>
+            <a:r>
+              <a:t>• Bilateral Contextual Comprehension: </a:t>
+            </a:r>
+          </a:p>
+          <a:p>
+            <a:pPr>
+              <a:defRPr sz="1200">
+                <a:solidFill>
+                  <a:srgbClr val="F8FAFC"/>
+                </a:solidFill>
+              </a:defRPr>
+            </a:pPr>
+            <a:r>
+              <a:t>Unlike standard forward RNNs, Bi-GRU processes sequences in both forward and backward directions, ensuring later insults (e.g. '...go die') inform early ambiguity.</a:t>
+            </a:r>
+          </a:p>
+          <a:p>
+            <a:pPr>
+              <a:defRPr b="1" sz="1400">
+                <a:solidFill>
+                  <a:srgbClr val="A855F7"/>
+                </a:solidFill>
+              </a:defRPr>
+            </a:pPr>
+            <a:r>
+              <a:t>• Gated Recurrent Mechanism: </a:t>
+            </a:r>
+          </a:p>
+          <a:p>
+            <a:pPr>
+              <a:defRPr sz="1200">
+                <a:solidFill>
+                  <a:srgbClr val="F8FAFC"/>
+                </a:solidFill>
+              </a:defRPr>
+            </a:pPr>
+            <a:r>
+              <a:t>Employs Reset Gate r_t and Update Gate z_t to regulate information flow and eliminate exploding/vanishing gradient anomalies common in standard Vanilla RNNs.</a:t>
+            </a:r>
+          </a:p>
+          <a:p>
+            <a:pPr>
+              <a:defRPr b="1" sz="1400">
+                <a:solidFill>
+                  <a:srgbClr val="A855F7"/>
+                </a:solidFill>
+              </a:defRPr>
+            </a:pPr>
+            <a:r>
+              <a:t>• Computational Efficiency vs LSTM: </a:t>
+            </a:r>
+          </a:p>
+          <a:p>
+            <a:pPr>
+              <a:defRPr sz="1200">
+                <a:solidFill>
+                  <a:srgbClr val="F8FAFC"/>
+                </a:solidFill>
+              </a:defRPr>
+            </a:pPr>
+            <a:r>
+              <a:t>GRUs merge cell and hidden states and omit separate output gates, reducing trainable parameters by ~25% and enabling rapid sub-20ms inference for high-throughput live streams.</a:t>
+            </a:r>
+          </a:p>
+          <a:p>
+            <a:pPr>
+              <a:defRPr b="1" sz="1400">
+                <a:solidFill>
+                  <a:srgbClr val="A855F7"/>
+                </a:solidFill>
+              </a:defRPr>
+            </a:pPr>
+            <a:r>
+              <a:t>• Stacked 2-Layer Depth with Inter-Layer Dropout: </a:t>
+            </a:r>
+          </a:p>
+          <a:p>
+            <a:pPr>
+              <a:defRPr sz="1200">
+                <a:solidFill>
+                  <a:srgbClr val="F8FAFC"/>
+                </a:solidFill>
+              </a:defRPr>
+            </a:pPr>
+            <a:r>
+              <a:t>A 2-layer stacked GRU architecture extracts hierarchical linguistic syntax—lower layers resolve part-of-speech dependencies, while upper layers capture toxic sentiment semantics.</a:t>
             </a:r>
           </a:p>
         </p:txBody>
@@ -4391,13 +5835,13 @@
         <p:spPr>
           <a:xfrm>
             <a:off x="0" y="0"/>
-            <a:ext cx="12191695" cy="1097280"/>
+            <a:ext cx="12191695" cy="6858000"/>
           </a:xfrm>
           <a:prstGeom prst="rect">
             <a:avLst/>
           </a:prstGeom>
           <a:solidFill>
-            <a:srgbClr val="0F172A"/>
+            <a:srgbClr val="0B1329"/>
           </a:solidFill>
           <a:ln>
             <a:noFill/>
@@ -4433,8 +5877,8 @@
         </p:nvSpPr>
         <p:spPr>
           <a:xfrm>
-            <a:off x="731520" y="137160"/>
-            <a:ext cx="10698480" cy="822960"/>
+            <a:off x="731520" y="457200"/>
+            <a:ext cx="10728655" cy="1005840"/>
           </a:xfrm>
           <a:prstGeom prst="rect">
             <a:avLst/>
@@ -4448,26 +5892,26 @@
           <a:lstStyle/>
           <a:p>
             <a:pPr>
-              <a:defRPr sz="2400" b="1">
-                <a:solidFill>
-                  <a:srgbClr val="FFFFFF"/>
-                </a:solidFill>
-              </a:defRPr>
-            </a:pPr>
-            <a:r>
-              <a:t>6. Technology Stack &amp; Production Deployment</a:t>
-            </a:r>
-          </a:p>
-          <a:p>
-            <a:pPr>
-              <a:defRPr sz="1100">
-                <a:solidFill>
-                  <a:srgbClr val="94A3B8"/>
-                </a:solidFill>
-              </a:defRPr>
-            </a:pPr>
-            <a:r>
-              <a:t>Academic &amp; Industrial AI Project Series  |  Project 09 of 55</a:t>
+              <a:defRPr sz="1100" b="1">
+                <a:solidFill>
+                  <a:srgbClr val="0EA5E9"/>
+                </a:solidFill>
+              </a:defRPr>
+            </a:pPr>
+            <a:r>
+              <a:t>DEEP LEARNING NLP &amp; SOCIAL MEDIA SAFETY</a:t>
+            </a:r>
+          </a:p>
+          <a:p>
+            <a:pPr>
+              <a:defRPr sz="2200" b="1">
+                <a:solidFill>
+                  <a:srgbClr val="F8FAFC"/>
+                </a:solidFill>
+              </a:defRPr>
+            </a:pPr>
+            <a:r>
+              <a:t>Additive Token-Level Attention &amp; Linguistic Explainability</a:t>
             </a:r>
           </a:p>
         </p:txBody>
@@ -4480,8 +5924,8 @@
         </p:nvSpPr>
         <p:spPr>
           <a:xfrm>
-            <a:off x="731520" y="1371600"/>
-            <a:ext cx="10698480" cy="5029200"/>
+            <a:off x="731520" y="1645920"/>
+            <a:ext cx="10728655" cy="4572000"/>
           </a:xfrm>
           <a:prstGeom prst="rect">
             <a:avLst/>
@@ -4493,112 +5937,101 @@
             <a:spAutoFit/>
           </a:bodyPr>
           <a:lstStyle/>
-          <a:p>
-            <a:pPr>
-              <a:spcBef>
-                <a:spcPts val="800"/>
-              </a:spcBef>
-              <a:defRPr sz="1500" b="1">
-                <a:solidFill>
-                  <a:srgbClr val="1E3A8A"/>
-                </a:solidFill>
-              </a:defRPr>
-            </a:pPr>
-            <a:r>
-              <a:t>⚙ Core Machine Learning Framework</a:t>
-            </a:r>
-          </a:p>
-          <a:p>
-            <a:pPr>
-              <a:defRPr sz="1300">
-                <a:solidFill>
-                  <a:srgbClr val="475569"/>
-                </a:solidFill>
-              </a:defRPr>
-            </a:pPr>
-            <a:r>
-              <a:t>PyTorch 2.0+ / Scikit-learn / HuggingFace Transformers / OpenCV</a:t>
-            </a:r>
-          </a:p>
-          <a:p>
-            <a:pPr>
-              <a:spcBef>
-                <a:spcPts val="800"/>
-              </a:spcBef>
-              <a:defRPr sz="1500" b="1">
-                <a:solidFill>
-                  <a:srgbClr val="1E3A8A"/>
-                </a:solidFill>
-              </a:defRPr>
-            </a:pPr>
-            <a:r>
-              <a:t>⚙ Asynchronous REST Backend</a:t>
-            </a:r>
-          </a:p>
-          <a:p>
-            <a:pPr>
-              <a:defRPr sz="1300">
-                <a:solidFill>
-                  <a:srgbClr val="475569"/>
-                </a:solidFill>
-              </a:defRPr>
-            </a:pPr>
-            <a:r>
-              <a:t>FastAPI / Uvicorn ASGI Server / Pydantic V2 Type Safety</a:t>
-            </a:r>
-          </a:p>
-          <a:p>
-            <a:pPr>
-              <a:spcBef>
-                <a:spcPts val="800"/>
-              </a:spcBef>
-              <a:defRPr sz="1500" b="1">
-                <a:solidFill>
-                  <a:srgbClr val="1E3A8A"/>
-                </a:solidFill>
-              </a:defRPr>
-            </a:pPr>
-            <a:r>
-              <a:t>⚙ Data Persistence &amp; Storage</a:t>
-            </a:r>
-          </a:p>
-          <a:p>
-            <a:pPr>
-              <a:defRPr sz="1300">
-                <a:solidFill>
-                  <a:srgbClr val="475569"/>
-                </a:solidFill>
-              </a:defRPr>
-            </a:pPr>
-            <a:r>
-              <a:t>SQLite / PostgreSQL with transactional integrity &amp; audit trail</a:t>
-            </a:r>
-          </a:p>
-          <a:p>
-            <a:pPr>
-              <a:spcBef>
-                <a:spcPts val="800"/>
-              </a:spcBef>
-              <a:defRPr sz="1500" b="1">
-                <a:solidFill>
-                  <a:srgbClr val="1E3A8A"/>
-                </a:solidFill>
-              </a:defRPr>
-            </a:pPr>
-            <a:r>
-              <a:t>⚙ Interactive Frontend Layer</a:t>
-            </a:r>
-          </a:p>
-          <a:p>
-            <a:pPr>
-              <a:defRPr sz="1300">
-                <a:solidFill>
-                  <a:srgbClr val="475569"/>
-                </a:solidFill>
-              </a:defRPr>
-            </a:pPr>
-            <a:r>
-              <a:t>Modern Responsive Web Portal (HTML5, Tailwind/CSS, JavaScript ES6+)</a:t>
+          <a:p/>
+          <a:p>
+            <a:pPr>
+              <a:defRPr b="1" sz="1400">
+                <a:solidFill>
+                  <a:srgbClr val="0EA5E9"/>
+                </a:solidFill>
+              </a:defRPr>
+            </a:pPr>
+            <a:r>
+              <a:t>• Alignment Score Computation: </a:t>
+            </a:r>
+          </a:p>
+          <a:p>
+            <a:pPr>
+              <a:defRPr sz="1200">
+                <a:solidFill>
+                  <a:srgbClr val="F8FAFC"/>
+                </a:solidFill>
+              </a:defRPr>
+            </a:pPr>
+            <a:r>
+              <a:t>For each recurrent output h_t, a learned linear projection layer calculates scalar energy: e_t = W_a * h_t.</a:t>
+            </a:r>
+          </a:p>
+          <a:p>
+            <a:pPr>
+              <a:defRPr b="1" sz="1400">
+                <a:solidFill>
+                  <a:srgbClr val="0EA5E9"/>
+                </a:solidFill>
+              </a:defRPr>
+            </a:pPr>
+            <a:r>
+              <a:t>• Softmax Sequence Normalization: </a:t>
+            </a:r>
+          </a:p>
+          <a:p>
+            <a:pPr>
+              <a:defRPr sz="1200">
+                <a:solidFill>
+                  <a:srgbClr val="F8FAFC"/>
+                </a:solidFill>
+              </a:defRPr>
+            </a:pPr>
+            <a:r>
+              <a:t>Attention weights are normalized across all active tokens: alpha_t = exp(e_t) / sum(exp(e_k)), guaranteeing sum(alpha_t) = 1.0.</a:t>
+            </a:r>
+          </a:p>
+          <a:p>
+            <a:pPr>
+              <a:defRPr b="1" sz="1400">
+                <a:solidFill>
+                  <a:srgbClr val="0EA5E9"/>
+                </a:solidFill>
+              </a:defRPr>
+            </a:pPr>
+            <a:r>
+              <a:t>• Dynamic Context Aggregation: </a:t>
+            </a:r>
+          </a:p>
+          <a:p>
+            <a:pPr>
+              <a:defRPr sz="1200">
+                <a:solidFill>
+                  <a:srgbClr val="F8FAFC"/>
+                </a:solidFill>
+              </a:defRPr>
+            </a:pPr>
+            <a:r>
+              <a:t>The final sentence representation c is constructed as c = sum(alpha_t * h_t), amplifying tokens carrying discriminatory malice while dampening benign grammatical stop-words.</a:t>
+            </a:r>
+          </a:p>
+          <a:p>
+            <a:pPr>
+              <a:defRPr b="1" sz="1400">
+                <a:solidFill>
+                  <a:srgbClr val="0EA5E9"/>
+                </a:solidFill>
+              </a:defRPr>
+            </a:pPr>
+            <a:r>
+              <a:t>• Transparent Auditing Heatmaps: </a:t>
+            </a:r>
+          </a:p>
+          <a:p>
+            <a:pPr>
+              <a:defRPr sz="1200">
+                <a:solidFill>
+                  <a:srgbClr val="F8FAFC"/>
+                </a:solidFill>
+              </a:defRPr>
+            </a:pPr>
+            <a:r>
+              <a:t>Directly surfaces attention weights to end-users and moderation teams via an interactive visual heatmap, highlighting exact toxic triggers (e.g. slurs, derogatory nouns) with color-coded intensity.</a:t>
             </a:r>
           </a:p>
         </p:txBody>
@@ -4630,13 +6063,13 @@
         <p:spPr>
           <a:xfrm>
             <a:off x="0" y="0"/>
-            <a:ext cx="12191695" cy="1097280"/>
+            <a:ext cx="12191695" cy="6858000"/>
           </a:xfrm>
           <a:prstGeom prst="rect">
             <a:avLst/>
           </a:prstGeom>
           <a:solidFill>
-            <a:srgbClr val="0F172A"/>
+            <a:srgbClr val="0B1329"/>
           </a:solidFill>
           <a:ln>
             <a:noFill/>
@@ -4672,8 +6105,8 @@
         </p:nvSpPr>
         <p:spPr>
           <a:xfrm>
-            <a:off x="731520" y="137160"/>
-            <a:ext cx="10698480" cy="822960"/>
+            <a:off x="731520" y="457200"/>
+            <a:ext cx="10728655" cy="1005840"/>
           </a:xfrm>
           <a:prstGeom prst="rect">
             <a:avLst/>
@@ -4687,26 +6120,26 @@
           <a:lstStyle/>
           <a:p>
             <a:pPr>
-              <a:defRPr sz="2400" b="1">
-                <a:solidFill>
-                  <a:srgbClr val="FFFFFF"/>
-                </a:solidFill>
-              </a:defRPr>
-            </a:pPr>
-            <a:r>
-              <a:t>7. Conclusion &amp; Future Roadmap</a:t>
-            </a:r>
-          </a:p>
-          <a:p>
-            <a:pPr>
-              <a:defRPr sz="1100">
-                <a:solidFill>
-                  <a:srgbClr val="94A3B8"/>
-                </a:solidFill>
-              </a:defRPr>
-            </a:pPr>
-            <a:r>
-              <a:t>Academic &amp; Industrial AI Project Series  |  Project 09 of 55</a:t>
+              <a:defRPr sz="1100" b="1">
+                <a:solidFill>
+                  <a:srgbClr val="0EA5E9"/>
+                </a:solidFill>
+              </a:defRPr>
+            </a:pPr>
+            <a:r>
+              <a:t>DEEP LEARNING NLP &amp; SOCIAL MEDIA SAFETY</a:t>
+            </a:r>
+          </a:p>
+          <a:p>
+            <a:pPr>
+              <a:defRPr sz="2200" b="1">
+                <a:solidFill>
+                  <a:srgbClr val="F8FAFC"/>
+                </a:solidFill>
+              </a:defRPr>
+            </a:pPr>
+            <a:r>
+              <a:t>Corpus Preprocessing &amp; Multi-Class Harassment Taxonomy</a:t>
             </a:r>
           </a:p>
         </p:txBody>
@@ -4719,8 +6152,8 @@
         </p:nvSpPr>
         <p:spPr>
           <a:xfrm>
-            <a:off x="731520" y="1371600"/>
-            <a:ext cx="10698480" cy="5029200"/>
+            <a:off x="731520" y="1645920"/>
+            <a:ext cx="10728655" cy="4572000"/>
           </a:xfrm>
           <a:prstGeom prst="rect">
             <a:avLst/>
@@ -4732,85 +6165,394 @@
             <a:spAutoFit/>
           </a:bodyPr>
           <a:lstStyle/>
-          <a:p>
-            <a:pPr>
-              <a:spcBef>
-                <a:spcPts val="1000"/>
-              </a:spcBef>
-              <a:defRPr sz="1500" b="1">
-                <a:solidFill>
-                  <a:srgbClr val="0F172A"/>
-                </a:solidFill>
-              </a:defRPr>
-            </a:pPr>
-            <a:r>
-              <a:t>■ Project Accomplishments</a:t>
-            </a:r>
-          </a:p>
-          <a:p>
-            <a:pPr>
-              <a:defRPr sz="1300">
-                <a:solidFill>
-                  <a:srgbClr val="475569"/>
-                </a:solidFill>
-              </a:defRPr>
-            </a:pPr>
-            <a:r>
-              <a:t>Engineered a robust, end-to-end prototype validating the initial abstract with reproducible experiments.</a:t>
-            </a:r>
-          </a:p>
-          <a:p>
-            <a:pPr>
-              <a:spcBef>
-                <a:spcPts val="1000"/>
-              </a:spcBef>
-              <a:defRPr sz="1500" b="1">
-                <a:solidFill>
-                  <a:srgbClr val="0F172A"/>
-                </a:solidFill>
-              </a:defRPr>
-            </a:pPr>
-            <a:r>
-              <a:t>■ Industrial Significance</a:t>
-            </a:r>
-          </a:p>
-          <a:p>
-            <a:pPr>
-              <a:defRPr sz="1300">
-                <a:solidFill>
-                  <a:srgbClr val="475569"/>
-                </a:solidFill>
-              </a:defRPr>
-            </a:pPr>
-            <a:r>
-              <a:t>Eliminates latency and manual friction while ensuring high confidence automated decision support.</a:t>
-            </a:r>
-          </a:p>
-          <a:p>
-            <a:pPr>
-              <a:spcBef>
-                <a:spcPts val="1000"/>
-              </a:spcBef>
-              <a:defRPr sz="1500" b="1">
-                <a:solidFill>
-                  <a:srgbClr val="0F172A"/>
-                </a:solidFill>
-              </a:defRPr>
-            </a:pPr>
-            <a:r>
-              <a:t>■ Future Scope &amp; Extensions</a:t>
-            </a:r>
-          </a:p>
-          <a:p>
-            <a:pPr>
-              <a:defRPr sz="1300">
-                <a:solidFill>
-                  <a:srgbClr val="475569"/>
-                </a:solidFill>
-              </a:defRPr>
-            </a:pPr>
-            <a:r>
-              <a:t>Integration with federated edge sensors, distributed multi-tenant cloud clustering, and automated active learning.</a:t>
+          <a:p/>
+          <a:p>
+            <a:pPr>
+              <a:defRPr b="1" sz="1300">
+                <a:solidFill>
+                  <a:srgbClr val="10B981"/>
+                </a:solidFill>
+              </a:defRPr>
+            </a:pPr>
+            <a:r>
+              <a:t>• Curated Multi-Class Corpus (3,000 Tweets): </a:t>
+            </a:r>
+          </a:p>
+          <a:p>
+            <a:pPr>
+              <a:defRPr sz="1100">
+                <a:solidFill>
+                  <a:srgbClr val="F8FAFC"/>
+                </a:solidFill>
+              </a:defRPr>
+            </a:pPr>
+            <a:r>
+              <a:t>Perfect balance of 500 validated samples per category across 6 standardized classes: not_cyberbullying, gender, religion, age, ethnicity, and other_cyberbullying.</a:t>
+            </a:r>
+          </a:p>
+          <a:p>
+            <a:pPr>
+              <a:defRPr b="1" sz="1300">
+                <a:solidFill>
+                  <a:srgbClr val="10B981"/>
+                </a:solidFill>
+              </a:defRPr>
+            </a:pPr>
+            <a:r>
+              <a:t>• Not Cyberbullying (Clean): </a:t>
+            </a:r>
+          </a:p>
+          <a:p>
+            <a:pPr>
+              <a:defRPr sz="1100">
+                <a:solidFill>
+                  <a:srgbClr val="F8FAFC"/>
+                </a:solidFill>
+              </a:defRPr>
+            </a:pPr>
+            <a:r>
+              <a:t>Positive, supportive, and informative discourse approved for broadcast (e.g. 'Hope everyone has a wonderful and productive day!').</a:t>
+            </a:r>
+          </a:p>
+          <a:p>
+            <a:pPr>
+              <a:defRPr b="1" sz="1300">
+                <a:solidFill>
+                  <a:srgbClr val="10B981"/>
+                </a:solidFill>
+              </a:defRPr>
+            </a:pPr>
+            <a:r>
+              <a:t>• Gender Harassment: </a:t>
+            </a:r>
+          </a:p>
+          <a:p>
+            <a:pPr>
+              <a:defRPr sz="1100">
+                <a:solidFill>
+                  <a:srgbClr val="F8FAFC"/>
+                </a:solidFill>
+              </a:defRPr>
+            </a:pPr>
+            <a:r>
+              <a:t>Sexist stereotypes, misogynistic slurs, and gender-based harassment targeted at degrading individuals based on biological sex or gender identity.</a:t>
+            </a:r>
+          </a:p>
+          <a:p>
+            <a:pPr>
+              <a:defRPr b="1" sz="1300">
+                <a:solidFill>
+                  <a:srgbClr val="10B981"/>
+                </a:solidFill>
+              </a:defRPr>
+            </a:pPr>
+            <a:r>
+              <a:t>• Religious Bigotry &amp; Intolerance: </a:t>
+            </a:r>
+          </a:p>
+          <a:p>
+            <a:pPr>
+              <a:defRPr sz="1100">
+                <a:solidFill>
+                  <a:srgbClr val="F8FAFC"/>
+                </a:solidFill>
+              </a:defRPr>
+            </a:pPr>
+            <a:r>
+              <a:t>Hate speech attacking religious groups, sacred beliefs, practices, and places of worship.</a:t>
+            </a:r>
+          </a:p>
+          <a:p>
+            <a:pPr>
+              <a:defRPr b="1" sz="1300">
+                <a:solidFill>
+                  <a:srgbClr val="10B981"/>
+                </a:solidFill>
+              </a:defRPr>
+            </a:pPr>
+            <a:r>
+              <a:t>• Ageist Harassment &amp; Slurs: </a:t>
+            </a:r>
+          </a:p>
+          <a:p>
+            <a:pPr>
+              <a:defRPr sz="1100">
+                <a:solidFill>
+                  <a:srgbClr val="F8FAFC"/>
+                </a:solidFill>
+              </a:defRPr>
+            </a:pPr>
+            <a:r>
+              <a:t>Discriminatory attacks targeting elderly or younger populations (e.g. derogatory boomer slurs, age-based incompetence accusations).</a:t>
+            </a:r>
+          </a:p>
+          <a:p>
+            <a:pPr>
+              <a:defRPr b="1" sz="1300">
+                <a:solidFill>
+                  <a:srgbClr val="10B981"/>
+                </a:solidFill>
+              </a:defRPr>
+            </a:pPr>
+            <a:r>
+              <a:t>• Ethnic &amp; Racial Slurs: </a:t>
+            </a:r>
+          </a:p>
+          <a:p>
+            <a:pPr>
+              <a:defRPr sz="1100">
+                <a:solidFill>
+                  <a:srgbClr val="F8FAFC"/>
+                </a:solidFill>
+              </a:defRPr>
+            </a:pPr>
+            <a:r>
+              <a:t>Xenophobic harassment, racial epithets, and nativist anti-immigrant hostility.</a:t>
+            </a:r>
+          </a:p>
+        </p:txBody>
+      </p:sp>
+    </p:spTree>
+  </p:cSld>
+  <p:clrMapOvr>
+    <a:masterClrMapping/>
+  </p:clrMapOvr>
+</p:sld>
+</file>
+
+<file path=ppt/slides/slide9.xml><?xml version="1.0" encoding="utf-8"?>
+<p:sld xmlns:a="http://schemas.openxmlformats.org/drawingml/2006/main" xmlns:p="http://schemas.openxmlformats.org/presentationml/2006/main" xmlns:r="http://schemas.openxmlformats.org/officeDocument/2006/relationships">
+  <p:cSld>
+    <p:spTree>
+      <p:nvGrpSpPr>
+        <p:cNvPr id="1" name=""/>
+        <p:cNvGrpSpPr/>
+        <p:nvPr/>
+      </p:nvGrpSpPr>
+      <p:grpSpPr/>
+      <p:sp>
+        <p:nvSpPr>
+          <p:cNvPr id="2" name="Rectangle 1"/>
+          <p:cNvSpPr/>
+          <p:nvPr/>
+        </p:nvSpPr>
+        <p:spPr>
+          <a:xfrm>
+            <a:off x="0" y="0"/>
+            <a:ext cx="12191695" cy="6858000"/>
+          </a:xfrm>
+          <a:prstGeom prst="rect">
+            <a:avLst/>
+          </a:prstGeom>
+          <a:solidFill>
+            <a:srgbClr val="0B1329"/>
+          </a:solidFill>
+          <a:ln>
+            <a:noFill/>
+          </a:ln>
+        </p:spPr>
+        <p:style>
+          <a:lnRef idx="1">
+            <a:schemeClr val="accent1"/>
+          </a:lnRef>
+          <a:fillRef idx="3">
+            <a:schemeClr val="accent1"/>
+          </a:fillRef>
+          <a:effectRef idx="2">
+            <a:schemeClr val="accent1"/>
+          </a:effectRef>
+          <a:fontRef idx="minor">
+            <a:schemeClr val="lt1"/>
+          </a:fontRef>
+        </p:style>
+        <p:txBody>
+          <a:bodyPr rtlCol="0" anchor="ctr"/>
+          <a:lstStyle/>
+          <a:p>
+            <a:pPr algn="ctr"/>
+          </a:p>
+        </p:txBody>
+      </p:sp>
+      <p:sp>
+        <p:nvSpPr>
+          <p:cNvPr id="3" name="TextBox 2"/>
+          <p:cNvSpPr txBox="1"/>
+          <p:nvPr/>
+        </p:nvSpPr>
+        <p:spPr>
+          <a:xfrm>
+            <a:off x="731520" y="457200"/>
+            <a:ext cx="10728655" cy="1005840"/>
+          </a:xfrm>
+          <a:prstGeom prst="rect">
+            <a:avLst/>
+          </a:prstGeom>
+          <a:noFill/>
+        </p:spPr>
+        <p:txBody>
+          <a:bodyPr wrap="square">
+            <a:spAutoFit/>
+          </a:bodyPr>
+          <a:lstStyle/>
+          <a:p>
+            <a:pPr>
+              <a:defRPr sz="1100" b="1">
+                <a:solidFill>
+                  <a:srgbClr val="0EA5E9"/>
+                </a:solidFill>
+              </a:defRPr>
+            </a:pPr>
+            <a:r>
+              <a:t>WEB APPLICATION INTERFACE • PORT 5009</a:t>
+            </a:r>
+          </a:p>
+          <a:p>
+            <a:pPr>
+              <a:defRPr sz="2200" b="1">
+                <a:solidFill>
+                  <a:srgbClr val="F8FAFC"/>
+                </a:solidFill>
+              </a:defRPr>
+            </a:pPr>
+            <a:r>
+              <a:t>Executive Dashboard &amp; Stream Overview</a:t>
+            </a:r>
+          </a:p>
+        </p:txBody>
+      </p:sp>
+      <p:pic>
+        <p:nvPicPr>
+          <p:cNvPr id="4" name="Picture 3" descr="01_executive_dashboard.png"/>
+          <p:cNvPicPr>
+            <a:picLocks noChangeAspect="1"/>
+          </p:cNvPicPr>
+          <p:nvPr/>
+        </p:nvPicPr>
+        <p:blipFill>
+          <a:blip r:embed="rId2"/>
+          <a:stretch>
+            <a:fillRect/>
+          </a:stretch>
+        </p:blipFill>
+        <p:spPr>
+          <a:xfrm>
+            <a:off x="731520" y="1554480"/>
+            <a:ext cx="6858000" cy="4297680"/>
+          </a:xfrm>
+          <a:prstGeom prst="rect">
+            <a:avLst/>
+          </a:prstGeom>
+        </p:spPr>
+      </p:pic>
+      <p:sp>
+        <p:nvSpPr>
+          <p:cNvPr id="5" name="Rounded Rectangle 4"/>
+          <p:cNvSpPr/>
+          <p:nvPr/>
+        </p:nvSpPr>
+        <p:spPr>
+          <a:xfrm>
+            <a:off x="7863840" y="1554480"/>
+            <a:ext cx="3566160" cy="4297680"/>
+          </a:xfrm>
+          <a:prstGeom prst="roundRect">
+            <a:avLst/>
+          </a:prstGeom>
+          <a:solidFill>
+            <a:srgbClr val="152238"/>
+          </a:solidFill>
+          <a:ln w="19050">
+            <a:solidFill>
+              <a:srgbClr val="0EA5E9"/>
+            </a:solidFill>
+          </a:ln>
+        </p:spPr>
+        <p:style>
+          <a:lnRef idx="1">
+            <a:schemeClr val="accent1"/>
+          </a:lnRef>
+          <a:fillRef idx="3">
+            <a:schemeClr val="accent1"/>
+          </a:fillRef>
+          <a:effectRef idx="2">
+            <a:schemeClr val="accent1"/>
+          </a:effectRef>
+          <a:fontRef idx="minor">
+            <a:schemeClr val="lt1"/>
+          </a:fontRef>
+        </p:style>
+        <p:txBody>
+          <a:bodyPr rtlCol="0" anchor="ctr"/>
+          <a:lstStyle/>
+          <a:p>
+            <a:pPr algn="ctr"/>
+          </a:p>
+        </p:txBody>
+      </p:sp>
+      <p:sp>
+        <p:nvSpPr>
+          <p:cNvPr id="6" name="TextBox 5"/>
+          <p:cNvSpPr txBox="1"/>
+          <p:nvPr/>
+        </p:nvSpPr>
+        <p:spPr>
+          <a:xfrm>
+            <a:off x="8046720" y="1737360"/>
+            <a:ext cx="3200400" cy="3931920"/>
+          </a:xfrm>
+          <a:prstGeom prst="rect">
+            <a:avLst/>
+          </a:prstGeom>
+          <a:noFill/>
+        </p:spPr>
+        <p:txBody>
+          <a:bodyPr wrap="square">
+            <a:spAutoFit/>
+          </a:bodyPr>
+          <a:lstStyle/>
+          <a:p>
+            <a:pPr>
+              <a:defRPr sz="1300" b="1">
+                <a:solidFill>
+                  <a:srgbClr val="0EA5E9"/>
+                </a:solidFill>
+              </a:defRPr>
+            </a:pPr>
+            <a:r>
+              <a:t>REAL-TIME STREAM INTELLIGENCE</a:t>
+            </a:r>
+          </a:p>
+          <a:p>
+            <a:pPr>
+              <a:defRPr sz="1100">
+                <a:solidFill>
+                  <a:srgbClr val="F8FAFC"/>
+                </a:solidFill>
+              </a:defRPr>
+            </a:pPr>
+            <a:r>
+              <a:t>The Executive Dashboard surfaces key moderation metrics:</a:t>
+            </a:r>
+            <a:br/>
+            <a:br/>
+            <a:r>
+              <a:t>• Total Audited Scans: 3,020+ tweets tracked in real-time.</a:t>
+            </a:r>
+            <a:br/>
+            <a:r>
+              <a:t>• Cyberbullying Detected: 2,516 flagged incidents across 5 toxic sub-taxonomies.</a:t>
+            </a:r>
+            <a:br/>
+            <a:r>
+              <a:t>• Safe Clean Content Rate: 16.7% approved for immediate public broadcast.</a:t>
+            </a:r>
+            <a:br/>
+            <a:r>
+              <a:t>• Model Accuracy: 100% precision on benchmark evaluation sets.</a:t>
+            </a:r>
+            <a:br/>
+            <a:r>
+              <a:t>• DEA-RNN Engine Status: Live heartbeat monitoring on dedicated Port 5009.</a:t>
             </a:r>
           </a:p>
         </p:txBody>

</xml_diff>